<commit_message>
Update accessibility documentation and package files
</commit_message>
<xml_diff>
--- a/BCHAIN-ACCESS_Package/images/Figure_1.pptx
+++ b/BCHAIN-ACCESS_Package/images/Figure_1.pptx
@@ -5,9 +5,9 @@
     <p:sldMasterId id="2147483648" r:id="rId1"/>
   </p:sldMasterIdLst>
   <p:sldIdLst>
-    <p:sldId id="256" r:id="rId7"/>
+    <p:sldId id="256" r:id="rId2"/>
   </p:sldIdLst>
-  <p:sldSz cx="12191695" cy="7619809" type="screen4x3"/>
+  <p:sldSz cx="12192000" cy="7620000"/>
   <p:notesSz cx="6858000" cy="9144000"/>
   <p:defaultTextStyle>
     <a:defPPr>
@@ -104,6 +104,22 @@
       </a:defRPr>
     </a:lvl9pPr>
   </p:defaultTextStyle>
+  <p:extLst>
+    <p:ext uri="{EFAFB233-063F-42B5-8137-9DF3F51BA10A}">
+      <p15:sldGuideLst xmlns:p15="http://schemas.microsoft.com/office/powerpoint/2012/main">
+        <p15:guide id="1" orient="horz" pos="2160">
+          <p15:clr>
+            <a:srgbClr val="A4A3A4"/>
+          </p15:clr>
+        </p15:guide>
+        <p15:guide id="2" pos="2880">
+          <p15:clr>
+            <a:srgbClr val="A4A3A4"/>
+          </p15:clr>
+        </p15:guide>
+      </p15:sldGuideLst>
+    </p:ext>
+  </p:extLst>
 </p:presentation>
 </file>
 
@@ -145,10 +161,9 @@
           <a:lstStyle/>
           <a:p>
             <a:r>
-              <a:rPr lang="en-US" smtClean="0"/>
+              <a:rPr lang="en-US"/>
               <a:t>Click to edit Master title style</a:t>
             </a:r>
-            <a:endParaRPr lang="en-US"/>
           </a:p>
         </p:txBody>
       </p:sp>
@@ -264,10 +279,9 @@
           </a:lstStyle>
           <a:p>
             <a:r>
-              <a:rPr lang="en-US" smtClean="0"/>
+              <a:rPr lang="en-US"/>
               <a:t>Click to edit Master subtitle style</a:t>
             </a:r>
-            <a:endParaRPr lang="en-US"/>
           </a:p>
         </p:txBody>
       </p:sp>
@@ -288,7 +302,7 @@
           <a:p>
             <a:fld id="{5BCAD085-E8A6-8845-BD4E-CB4CCA059FC4}" type="datetimeFigureOut">
               <a:rPr lang="en-US" smtClean="0"/>
-              <a:t>1/27/13</a:t>
+              <a:t>7/13/2026</a:t>
             </a:fld>
             <a:endParaRPr lang="en-US"/>
           </a:p>
@@ -382,10 +396,9 @@
           <a:lstStyle/>
           <a:p>
             <a:r>
-              <a:rPr lang="en-US" smtClean="0"/>
+              <a:rPr lang="en-US"/>
               <a:t>Click to edit Master title style</a:t>
             </a:r>
-            <a:endParaRPr lang="en-US"/>
           </a:p>
         </p:txBody>
       </p:sp>
@@ -406,38 +419,37 @@
           <a:p>
             <a:pPr lvl="0"/>
             <a:r>
-              <a:rPr lang="en-US" smtClean="0"/>
+              <a:rPr lang="en-US"/>
               <a:t>Click to edit Master text styles</a:t>
             </a:r>
           </a:p>
           <a:p>
             <a:pPr lvl="1"/>
             <a:r>
-              <a:rPr lang="en-US" smtClean="0"/>
+              <a:rPr lang="en-US"/>
               <a:t>Second level</a:t>
             </a:r>
           </a:p>
           <a:p>
             <a:pPr lvl="2"/>
             <a:r>
-              <a:rPr lang="en-US" smtClean="0"/>
+              <a:rPr lang="en-US"/>
               <a:t>Third level</a:t>
             </a:r>
           </a:p>
           <a:p>
             <a:pPr lvl="3"/>
             <a:r>
-              <a:rPr lang="en-US" smtClean="0"/>
+              <a:rPr lang="en-US"/>
               <a:t>Fourth level</a:t>
             </a:r>
           </a:p>
           <a:p>
             <a:pPr lvl="4"/>
             <a:r>
-              <a:rPr lang="en-US" smtClean="0"/>
+              <a:rPr lang="en-US"/>
               <a:t>Fifth level</a:t>
             </a:r>
-            <a:endParaRPr lang="en-US"/>
           </a:p>
         </p:txBody>
       </p:sp>
@@ -458,7 +470,7 @@
           <a:p>
             <a:fld id="{5BCAD085-E8A6-8845-BD4E-CB4CCA059FC4}" type="datetimeFigureOut">
               <a:rPr lang="en-US" smtClean="0"/>
-              <a:t>1/27/13</a:t>
+              <a:t>7/13/2026</a:t>
             </a:fld>
             <a:endParaRPr lang="en-US"/>
           </a:p>
@@ -557,10 +569,9 @@
           <a:lstStyle/>
           <a:p>
             <a:r>
-              <a:rPr lang="en-US" smtClean="0"/>
+              <a:rPr lang="en-US"/>
               <a:t>Click to edit Master title style</a:t>
             </a:r>
-            <a:endParaRPr lang="en-US"/>
           </a:p>
         </p:txBody>
       </p:sp>
@@ -586,38 +597,37 @@
           <a:p>
             <a:pPr lvl="0"/>
             <a:r>
-              <a:rPr lang="en-US" smtClean="0"/>
+              <a:rPr lang="en-US"/>
               <a:t>Click to edit Master text styles</a:t>
             </a:r>
           </a:p>
           <a:p>
             <a:pPr lvl="1"/>
             <a:r>
-              <a:rPr lang="en-US" smtClean="0"/>
+              <a:rPr lang="en-US"/>
               <a:t>Second level</a:t>
             </a:r>
           </a:p>
           <a:p>
             <a:pPr lvl="2"/>
             <a:r>
-              <a:rPr lang="en-US" smtClean="0"/>
+              <a:rPr lang="en-US"/>
               <a:t>Third level</a:t>
             </a:r>
           </a:p>
           <a:p>
             <a:pPr lvl="3"/>
             <a:r>
-              <a:rPr lang="en-US" smtClean="0"/>
+              <a:rPr lang="en-US"/>
               <a:t>Fourth level</a:t>
             </a:r>
           </a:p>
           <a:p>
             <a:pPr lvl="4"/>
             <a:r>
-              <a:rPr lang="en-US" smtClean="0"/>
+              <a:rPr lang="en-US"/>
               <a:t>Fifth level</a:t>
             </a:r>
-            <a:endParaRPr lang="en-US"/>
           </a:p>
         </p:txBody>
       </p:sp>
@@ -638,7 +648,7 @@
           <a:p>
             <a:fld id="{5BCAD085-E8A6-8845-BD4E-CB4CCA059FC4}" type="datetimeFigureOut">
               <a:rPr lang="en-US" smtClean="0"/>
-              <a:t>1/27/13</a:t>
+              <a:t>7/13/2026</a:t>
             </a:fld>
             <a:endParaRPr lang="en-US"/>
           </a:p>
@@ -732,10 +742,9 @@
           <a:lstStyle/>
           <a:p>
             <a:r>
-              <a:rPr lang="en-US" smtClean="0"/>
+              <a:rPr lang="en-US"/>
               <a:t>Click to edit Master title style</a:t>
             </a:r>
-            <a:endParaRPr lang="en-US"/>
           </a:p>
         </p:txBody>
       </p:sp>
@@ -756,38 +765,37 @@
           <a:p>
             <a:pPr lvl="0"/>
             <a:r>
-              <a:rPr lang="en-US" smtClean="0"/>
+              <a:rPr lang="en-US"/>
               <a:t>Click to edit Master text styles</a:t>
             </a:r>
           </a:p>
           <a:p>
             <a:pPr lvl="1"/>
             <a:r>
-              <a:rPr lang="en-US" smtClean="0"/>
+              <a:rPr lang="en-US"/>
               <a:t>Second level</a:t>
             </a:r>
           </a:p>
           <a:p>
             <a:pPr lvl="2"/>
             <a:r>
-              <a:rPr lang="en-US" smtClean="0"/>
+              <a:rPr lang="en-US"/>
               <a:t>Third level</a:t>
             </a:r>
           </a:p>
           <a:p>
             <a:pPr lvl="3"/>
             <a:r>
-              <a:rPr lang="en-US" smtClean="0"/>
+              <a:rPr lang="en-US"/>
               <a:t>Fourth level</a:t>
             </a:r>
           </a:p>
           <a:p>
             <a:pPr lvl="4"/>
             <a:r>
-              <a:rPr lang="en-US" smtClean="0"/>
+              <a:rPr lang="en-US"/>
               <a:t>Fifth level</a:t>
             </a:r>
-            <a:endParaRPr lang="en-US"/>
           </a:p>
         </p:txBody>
       </p:sp>
@@ -808,7 +816,7 @@
           <a:p>
             <a:fld id="{5BCAD085-E8A6-8845-BD4E-CB4CCA059FC4}" type="datetimeFigureOut">
               <a:rPr lang="en-US" smtClean="0"/>
-              <a:t>1/27/13</a:t>
+              <a:t>7/13/2026</a:t>
             </a:fld>
             <a:endParaRPr lang="en-US"/>
           </a:p>
@@ -911,10 +919,9 @@
           </a:lstStyle>
           <a:p>
             <a:r>
-              <a:rPr lang="en-US" smtClean="0"/>
+              <a:rPr lang="en-US"/>
               <a:t>Click to edit Master title style</a:t>
             </a:r>
-            <a:endParaRPr lang="en-US"/>
           </a:p>
         </p:txBody>
       </p:sp>
@@ -1031,7 +1038,7 @@
           <a:p>
             <a:pPr lvl="0"/>
             <a:r>
-              <a:rPr lang="en-US" smtClean="0"/>
+              <a:rPr lang="en-US"/>
               <a:t>Click to edit Master text styles</a:t>
             </a:r>
           </a:p>
@@ -1054,7 +1061,7 @@
           <a:p>
             <a:fld id="{5BCAD085-E8A6-8845-BD4E-CB4CCA059FC4}" type="datetimeFigureOut">
               <a:rPr lang="en-US" smtClean="0"/>
-              <a:t>1/27/13</a:t>
+              <a:t>7/13/2026</a:t>
             </a:fld>
             <a:endParaRPr lang="en-US"/>
           </a:p>
@@ -1148,10 +1155,9 @@
           <a:lstStyle/>
           <a:p>
             <a:r>
-              <a:rPr lang="en-US" smtClean="0"/>
+              <a:rPr lang="en-US"/>
               <a:t>Click to edit Master title style</a:t>
             </a:r>
-            <a:endParaRPr lang="en-US"/>
           </a:p>
         </p:txBody>
       </p:sp>
@@ -1205,38 +1211,37 @@
           <a:p>
             <a:pPr lvl="0"/>
             <a:r>
-              <a:rPr lang="en-US" smtClean="0"/>
+              <a:rPr lang="en-US"/>
               <a:t>Click to edit Master text styles</a:t>
             </a:r>
           </a:p>
           <a:p>
             <a:pPr lvl="1"/>
             <a:r>
-              <a:rPr lang="en-US" smtClean="0"/>
+              <a:rPr lang="en-US"/>
               <a:t>Second level</a:t>
             </a:r>
           </a:p>
           <a:p>
             <a:pPr lvl="2"/>
             <a:r>
-              <a:rPr lang="en-US" smtClean="0"/>
+              <a:rPr lang="en-US"/>
               <a:t>Third level</a:t>
             </a:r>
           </a:p>
           <a:p>
             <a:pPr lvl="3"/>
             <a:r>
-              <a:rPr lang="en-US" smtClean="0"/>
+              <a:rPr lang="en-US"/>
               <a:t>Fourth level</a:t>
             </a:r>
           </a:p>
           <a:p>
             <a:pPr lvl="4"/>
             <a:r>
-              <a:rPr lang="en-US" smtClean="0"/>
+              <a:rPr lang="en-US"/>
               <a:t>Fifth level</a:t>
             </a:r>
-            <a:endParaRPr lang="en-US"/>
           </a:p>
         </p:txBody>
       </p:sp>
@@ -1290,38 +1295,37 @@
           <a:p>
             <a:pPr lvl="0"/>
             <a:r>
-              <a:rPr lang="en-US" smtClean="0"/>
+              <a:rPr lang="en-US"/>
               <a:t>Click to edit Master text styles</a:t>
             </a:r>
           </a:p>
           <a:p>
             <a:pPr lvl="1"/>
             <a:r>
-              <a:rPr lang="en-US" smtClean="0"/>
+              <a:rPr lang="en-US"/>
               <a:t>Second level</a:t>
             </a:r>
           </a:p>
           <a:p>
             <a:pPr lvl="2"/>
             <a:r>
-              <a:rPr lang="en-US" smtClean="0"/>
+              <a:rPr lang="en-US"/>
               <a:t>Third level</a:t>
             </a:r>
           </a:p>
           <a:p>
             <a:pPr lvl="3"/>
             <a:r>
-              <a:rPr lang="en-US" smtClean="0"/>
+              <a:rPr lang="en-US"/>
               <a:t>Fourth level</a:t>
             </a:r>
           </a:p>
           <a:p>
             <a:pPr lvl="4"/>
             <a:r>
-              <a:rPr lang="en-US" smtClean="0"/>
+              <a:rPr lang="en-US"/>
               <a:t>Fifth level</a:t>
             </a:r>
-            <a:endParaRPr lang="en-US"/>
           </a:p>
         </p:txBody>
       </p:sp>
@@ -1342,7 +1346,7 @@
           <a:p>
             <a:fld id="{5BCAD085-E8A6-8845-BD4E-CB4CCA059FC4}" type="datetimeFigureOut">
               <a:rPr lang="en-US" smtClean="0"/>
-              <a:t>1/27/13</a:t>
+              <a:t>7/13/2026</a:t>
             </a:fld>
             <a:endParaRPr lang="en-US"/>
           </a:p>
@@ -1440,10 +1444,9 @@
           </a:lstStyle>
           <a:p>
             <a:r>
-              <a:rPr lang="en-US" smtClean="0"/>
+              <a:rPr lang="en-US"/>
               <a:t>Click to edit Master title style</a:t>
             </a:r>
-            <a:endParaRPr lang="en-US"/>
           </a:p>
         </p:txBody>
       </p:sp>
@@ -1506,7 +1509,7 @@
           <a:p>
             <a:pPr lvl="0"/>
             <a:r>
-              <a:rPr lang="en-US" smtClean="0"/>
+              <a:rPr lang="en-US"/>
               <a:t>Click to edit Master text styles</a:t>
             </a:r>
           </a:p>
@@ -1562,38 +1565,37 @@
           <a:p>
             <a:pPr lvl="0"/>
             <a:r>
-              <a:rPr lang="en-US" smtClean="0"/>
+              <a:rPr lang="en-US"/>
               <a:t>Click to edit Master text styles</a:t>
             </a:r>
           </a:p>
           <a:p>
             <a:pPr lvl="1"/>
             <a:r>
-              <a:rPr lang="en-US" smtClean="0"/>
+              <a:rPr lang="en-US"/>
               <a:t>Second level</a:t>
             </a:r>
           </a:p>
           <a:p>
             <a:pPr lvl="2"/>
             <a:r>
-              <a:rPr lang="en-US" smtClean="0"/>
+              <a:rPr lang="en-US"/>
               <a:t>Third level</a:t>
             </a:r>
           </a:p>
           <a:p>
             <a:pPr lvl="3"/>
             <a:r>
-              <a:rPr lang="en-US" smtClean="0"/>
+              <a:rPr lang="en-US"/>
               <a:t>Fourth level</a:t>
             </a:r>
           </a:p>
           <a:p>
             <a:pPr lvl="4"/>
             <a:r>
-              <a:rPr lang="en-US" smtClean="0"/>
+              <a:rPr lang="en-US"/>
               <a:t>Fifth level</a:t>
             </a:r>
-            <a:endParaRPr lang="en-US"/>
           </a:p>
         </p:txBody>
       </p:sp>
@@ -1656,7 +1658,7 @@
           <a:p>
             <a:pPr lvl="0"/>
             <a:r>
-              <a:rPr lang="en-US" smtClean="0"/>
+              <a:rPr lang="en-US"/>
               <a:t>Click to edit Master text styles</a:t>
             </a:r>
           </a:p>
@@ -1712,38 +1714,37 @@
           <a:p>
             <a:pPr lvl="0"/>
             <a:r>
-              <a:rPr lang="en-US" smtClean="0"/>
+              <a:rPr lang="en-US"/>
               <a:t>Click to edit Master text styles</a:t>
             </a:r>
           </a:p>
           <a:p>
             <a:pPr lvl="1"/>
             <a:r>
-              <a:rPr lang="en-US" smtClean="0"/>
+              <a:rPr lang="en-US"/>
               <a:t>Second level</a:t>
             </a:r>
           </a:p>
           <a:p>
             <a:pPr lvl="2"/>
             <a:r>
-              <a:rPr lang="en-US" smtClean="0"/>
+              <a:rPr lang="en-US"/>
               <a:t>Third level</a:t>
             </a:r>
           </a:p>
           <a:p>
             <a:pPr lvl="3"/>
             <a:r>
-              <a:rPr lang="en-US" smtClean="0"/>
+              <a:rPr lang="en-US"/>
               <a:t>Fourth level</a:t>
             </a:r>
           </a:p>
           <a:p>
             <a:pPr lvl="4"/>
             <a:r>
-              <a:rPr lang="en-US" smtClean="0"/>
+              <a:rPr lang="en-US"/>
               <a:t>Fifth level</a:t>
             </a:r>
-            <a:endParaRPr lang="en-US"/>
           </a:p>
         </p:txBody>
       </p:sp>
@@ -1764,7 +1765,7 @@
           <a:p>
             <a:fld id="{5BCAD085-E8A6-8845-BD4E-CB4CCA059FC4}" type="datetimeFigureOut">
               <a:rPr lang="en-US" smtClean="0"/>
-              <a:t>1/27/13</a:t>
+              <a:t>7/13/2026</a:t>
             </a:fld>
             <a:endParaRPr lang="en-US"/>
           </a:p>
@@ -1858,10 +1859,9 @@
           <a:lstStyle/>
           <a:p>
             <a:r>
-              <a:rPr lang="en-US" smtClean="0"/>
+              <a:rPr lang="en-US"/>
               <a:t>Click to edit Master title style</a:t>
             </a:r>
-            <a:endParaRPr lang="en-US"/>
           </a:p>
         </p:txBody>
       </p:sp>
@@ -1882,7 +1882,7 @@
           <a:p>
             <a:fld id="{5BCAD085-E8A6-8845-BD4E-CB4CCA059FC4}" type="datetimeFigureOut">
               <a:rPr lang="en-US" smtClean="0"/>
-              <a:t>1/27/13</a:t>
+              <a:t>7/13/2026</a:t>
             </a:fld>
             <a:endParaRPr lang="en-US"/>
           </a:p>
@@ -1977,7 +1977,7 @@
           <a:p>
             <a:fld id="{5BCAD085-E8A6-8845-BD4E-CB4CCA059FC4}" type="datetimeFigureOut">
               <a:rPr lang="en-US" smtClean="0"/>
-              <a:t>1/27/13</a:t>
+              <a:t>7/13/2026</a:t>
             </a:fld>
             <a:endParaRPr lang="en-US"/>
           </a:p>
@@ -2080,10 +2080,9 @@
           </a:lstStyle>
           <a:p>
             <a:r>
-              <a:rPr lang="en-US" smtClean="0"/>
+              <a:rPr lang="en-US"/>
               <a:t>Click to edit Master title style</a:t>
             </a:r>
-            <a:endParaRPr lang="en-US"/>
           </a:p>
         </p:txBody>
       </p:sp>
@@ -2137,38 +2136,37 @@
           <a:p>
             <a:pPr lvl="0"/>
             <a:r>
-              <a:rPr lang="en-US" smtClean="0"/>
+              <a:rPr lang="en-US"/>
               <a:t>Click to edit Master text styles</a:t>
             </a:r>
           </a:p>
           <a:p>
             <a:pPr lvl="1"/>
             <a:r>
-              <a:rPr lang="en-US" smtClean="0"/>
+              <a:rPr lang="en-US"/>
               <a:t>Second level</a:t>
             </a:r>
           </a:p>
           <a:p>
             <a:pPr lvl="2"/>
             <a:r>
-              <a:rPr lang="en-US" smtClean="0"/>
+              <a:rPr lang="en-US"/>
               <a:t>Third level</a:t>
             </a:r>
           </a:p>
           <a:p>
             <a:pPr lvl="3"/>
             <a:r>
-              <a:rPr lang="en-US" smtClean="0"/>
+              <a:rPr lang="en-US"/>
               <a:t>Fourth level</a:t>
             </a:r>
           </a:p>
           <a:p>
             <a:pPr lvl="4"/>
             <a:r>
-              <a:rPr lang="en-US" smtClean="0"/>
+              <a:rPr lang="en-US"/>
               <a:t>Fifth level</a:t>
             </a:r>
-            <a:endParaRPr lang="en-US"/>
           </a:p>
         </p:txBody>
       </p:sp>
@@ -2231,7 +2229,7 @@
           <a:p>
             <a:pPr lvl="0"/>
             <a:r>
-              <a:rPr lang="en-US" smtClean="0"/>
+              <a:rPr lang="en-US"/>
               <a:t>Click to edit Master text styles</a:t>
             </a:r>
           </a:p>
@@ -2254,7 +2252,7 @@
           <a:p>
             <a:fld id="{5BCAD085-E8A6-8845-BD4E-CB4CCA059FC4}" type="datetimeFigureOut">
               <a:rPr lang="en-US" smtClean="0"/>
-              <a:t>1/27/13</a:t>
+              <a:t>7/13/2026</a:t>
             </a:fld>
             <a:endParaRPr lang="en-US"/>
           </a:p>
@@ -2357,10 +2355,9 @@
           </a:lstStyle>
           <a:p>
             <a:r>
-              <a:rPr lang="en-US" smtClean="0"/>
+              <a:rPr lang="en-US"/>
               <a:t>Click to edit Master title style</a:t>
             </a:r>
-            <a:endParaRPr lang="en-US"/>
           </a:p>
         </p:txBody>
       </p:sp>
@@ -2484,7 +2481,7 @@
           <a:p>
             <a:pPr lvl="0"/>
             <a:r>
-              <a:rPr lang="en-US" smtClean="0"/>
+              <a:rPr lang="en-US"/>
               <a:t>Click to edit Master text styles</a:t>
             </a:r>
           </a:p>
@@ -2507,7 +2504,7 @@
           <a:p>
             <a:fld id="{5BCAD085-E8A6-8845-BD4E-CB4CCA059FC4}" type="datetimeFigureOut">
               <a:rPr lang="en-US" smtClean="0"/>
-              <a:t>1/27/13</a:t>
+              <a:t>7/13/2026</a:t>
             </a:fld>
             <a:endParaRPr lang="en-US"/>
           </a:p>
@@ -2616,10 +2613,9 @@
           <a:lstStyle/>
           <a:p>
             <a:r>
-              <a:rPr lang="en-US" smtClean="0"/>
+              <a:rPr lang="en-US"/>
               <a:t>Click to edit Master title style</a:t>
             </a:r>
-            <a:endParaRPr lang="en-US"/>
           </a:p>
         </p:txBody>
       </p:sp>
@@ -2650,38 +2646,37 @@
           <a:p>
             <a:pPr lvl="0"/>
             <a:r>
-              <a:rPr lang="en-US" smtClean="0"/>
+              <a:rPr lang="en-US"/>
               <a:t>Click to edit Master text styles</a:t>
             </a:r>
           </a:p>
           <a:p>
             <a:pPr lvl="1"/>
             <a:r>
-              <a:rPr lang="en-US" smtClean="0"/>
+              <a:rPr lang="en-US"/>
               <a:t>Second level</a:t>
             </a:r>
           </a:p>
           <a:p>
             <a:pPr lvl="2"/>
             <a:r>
-              <a:rPr lang="en-US" smtClean="0"/>
+              <a:rPr lang="en-US"/>
               <a:t>Third level</a:t>
             </a:r>
           </a:p>
           <a:p>
             <a:pPr lvl="3"/>
             <a:r>
-              <a:rPr lang="en-US" smtClean="0"/>
+              <a:rPr lang="en-US"/>
               <a:t>Fourth level</a:t>
             </a:r>
           </a:p>
           <a:p>
             <a:pPr lvl="4"/>
             <a:r>
-              <a:rPr lang="en-US" smtClean="0"/>
+              <a:rPr lang="en-US"/>
               <a:t>Fifth level</a:t>
             </a:r>
-            <a:endParaRPr lang="en-US"/>
           </a:p>
         </p:txBody>
       </p:sp>
@@ -2720,7 +2715,7 @@
           <a:p>
             <a:fld id="{5BCAD085-E8A6-8845-BD4E-CB4CCA059FC4}" type="datetimeFigureOut">
               <a:rPr lang="en-US" smtClean="0"/>
-              <a:t>1/27/13</a:t>
+              <a:t>7/13/2026</a:t>
             </a:fld>
             <a:endParaRPr lang="en-US"/>
           </a:p>
@@ -3079,7 +3074,7 @@
 </file>
 
 <file path=ppt/slides/slide1.xml><?xml version="1.0" encoding="utf-8"?>
-<p:sld xmlns:a="http://schemas.openxmlformats.org/drawingml/2006/main" xmlns:p="http://schemas.openxmlformats.org/presentationml/2006/main" xmlns:r="http://schemas.openxmlformats.org/officeDocument/2006/relationships">
+<p:sld xmlns:a="http://schemas.openxmlformats.org/drawingml/2006/main" xmlns:r="http://schemas.openxmlformats.org/officeDocument/2006/relationships" xmlns:p="http://schemas.openxmlformats.org/presentationml/2006/main">
   <p:cSld>
     <p:spTree>
       <p:nvGrpSpPr>
@@ -3087,10 +3082,3047 @@
         <p:cNvGrpSpPr/>
         <p:nvPr/>
       </p:nvGrpSpPr>
-      <p:grpSpPr/>
+      <p:grpSpPr>
+        <a:xfrm>
+          <a:off x="0" y="0"/>
+          <a:ext cx="0" cy="0"/>
+          <a:chOff x="0" y="0"/>
+          <a:chExt cx="0" cy="0"/>
+        </a:xfrm>
+      </p:grpSpPr>
+      <p:sp>
+        <p:nvSpPr>
+          <p:cNvPr id="2" name="Rounded Rectangle 1"/>
+          <p:cNvSpPr/>
+          <p:nvPr/>
+        </p:nvSpPr>
+        <p:spPr>
+          <a:xfrm>
+            <a:off x="228594" y="114297"/>
+            <a:ext cx="1706837" cy="761980"/>
+          </a:xfrm>
+          <a:prstGeom prst="roundRect">
+            <a:avLst>
+              <a:gd name="adj" fmla="val 10000"/>
+            </a:avLst>
+          </a:prstGeom>
+          <a:solidFill>
+            <a:srgbClr val="00428D"/>
+          </a:solidFill>
+          <a:ln>
+            <a:noFill/>
+          </a:ln>
+        </p:spPr>
+        <p:style>
+          <a:lnRef idx="1">
+            <a:schemeClr val="accent1"/>
+          </a:lnRef>
+          <a:fillRef idx="3">
+            <a:schemeClr val="accent1"/>
+          </a:fillRef>
+          <a:effectRef idx="2">
+            <a:schemeClr val="accent1"/>
+          </a:effectRef>
+          <a:fontRef idx="minor">
+            <a:schemeClr val="lt1"/>
+          </a:fontRef>
+        </p:style>
+        <p:txBody>
+          <a:bodyPr rtlCol="0" anchor="ctr"/>
+          <a:lstStyle/>
+          <a:p>
+            <a:pPr algn="ctr"/>
+            <a:endParaRPr/>
+          </a:p>
+        </p:txBody>
+      </p:sp>
+      <p:sp>
+        <p:nvSpPr>
+          <p:cNvPr id="3" name="Oval 2"/>
+          <p:cNvSpPr/>
+          <p:nvPr/>
+        </p:nvSpPr>
+        <p:spPr>
+          <a:xfrm>
+            <a:off x="248821" y="87753"/>
+            <a:ext cx="289552" cy="289552"/>
+          </a:xfrm>
+          <a:prstGeom prst="ellipse">
+            <a:avLst/>
+          </a:prstGeom>
+          <a:solidFill>
+            <a:srgbClr val="FFFFFF"/>
+          </a:solidFill>
+          <a:ln w="20320">
+            <a:solidFill>
+              <a:srgbClr val="2E4A9E"/>
+            </a:solidFill>
+          </a:ln>
+          <a:effectLst/>
+        </p:spPr>
+        <p:style>
+          <a:lnRef idx="1">
+            <a:schemeClr val="accent1"/>
+          </a:lnRef>
+          <a:fillRef idx="3">
+            <a:schemeClr val="accent1"/>
+          </a:fillRef>
+          <a:effectRef idx="2">
+            <a:schemeClr val="accent1"/>
+          </a:effectRef>
+          <a:fontRef idx="minor">
+            <a:schemeClr val="lt1"/>
+          </a:fontRef>
+        </p:style>
+        <p:txBody>
+          <a:bodyPr wrap="square" lIns="36576" tIns="18288" rIns="36576" bIns="18288" rtlCol="0" anchor="ctr"/>
+          <a:lstStyle/>
+          <a:p>
+            <a:pPr algn="ctr">
+              <a:spcBef>
+                <a:spcPts val="0"/>
+              </a:spcBef>
+              <a:spcAft>
+                <a:spcPts val="0"/>
+              </a:spcAft>
+            </a:pPr>
+            <a:r>
+              <a:rPr sz="1100" b="1" i="0">
+                <a:solidFill>
+                  <a:srgbClr val="2E4A9E"/>
+                </a:solidFill>
+                <a:latin typeface="Times New Roman" panose="02020603050405020304" pitchFamily="18" charset="0"/>
+                <a:cs typeface="Times New Roman" panose="02020603050405020304" pitchFamily="18" charset="0"/>
+              </a:rPr>
+              <a:t>1</a:t>
+            </a:r>
+          </a:p>
+        </p:txBody>
+      </p:sp>
+      <p:sp>
+        <p:nvSpPr>
+          <p:cNvPr id="4" name="TextBox 3"/>
+          <p:cNvSpPr txBox="1"/>
+          <p:nvPr/>
+        </p:nvSpPr>
+        <p:spPr>
+          <a:xfrm>
+            <a:off x="266999" y="402517"/>
+            <a:ext cx="1805588" cy="406265"/>
+          </a:xfrm>
+          <a:prstGeom prst="rect">
+            <a:avLst/>
+          </a:prstGeom>
+          <a:noFill/>
+        </p:spPr>
+        <p:txBody>
+          <a:bodyPr wrap="square" lIns="36576" tIns="18288" rIns="36576" bIns="18288" anchor="ctr">
+            <a:spAutoFit/>
+          </a:bodyPr>
+          <a:lstStyle/>
+          <a:p>
+            <a:pPr algn="l">
+              <a:spcBef>
+                <a:spcPts val="0"/>
+              </a:spcBef>
+              <a:spcAft>
+                <a:spcPts val="200"/>
+              </a:spcAft>
+            </a:pPr>
+            <a:r>
+              <a:rPr sz="1200" b="1" i="0" dirty="0">
+                <a:solidFill>
+                  <a:srgbClr val="FFFFFF"/>
+                </a:solidFill>
+                <a:latin typeface="Times New Roman" panose="02020603050405020304" pitchFamily="18" charset="0"/>
+                <a:cs typeface="Times New Roman" panose="02020603050405020304" pitchFamily="18" charset="0"/>
+              </a:rPr>
+              <a:t>PROBLEM  AND MOTIVATION</a:t>
+            </a:r>
+          </a:p>
+        </p:txBody>
+      </p:sp>
+      <p:sp>
+        <p:nvSpPr>
+          <p:cNvPr id="5" name="Rounded Rectangle 4"/>
+          <p:cNvSpPr/>
+          <p:nvPr/>
+        </p:nvSpPr>
+        <p:spPr>
+          <a:xfrm>
+            <a:off x="228594" y="952475"/>
+            <a:ext cx="1706837" cy="3833563"/>
+          </a:xfrm>
+          <a:prstGeom prst="roundRect">
+            <a:avLst>
+              <a:gd name="adj" fmla="val 5000"/>
+            </a:avLst>
+          </a:prstGeom>
+          <a:solidFill>
+            <a:srgbClr val="FFFFFF"/>
+          </a:solidFill>
+          <a:ln w="19050">
+            <a:solidFill>
+              <a:srgbClr val="00428D"/>
+            </a:solidFill>
+          </a:ln>
+        </p:spPr>
+        <p:style>
+          <a:lnRef idx="1">
+            <a:schemeClr val="accent1"/>
+          </a:lnRef>
+          <a:fillRef idx="3">
+            <a:schemeClr val="accent1"/>
+          </a:fillRef>
+          <a:effectRef idx="2">
+            <a:schemeClr val="accent1"/>
+          </a:effectRef>
+          <a:fontRef idx="minor">
+            <a:schemeClr val="lt1"/>
+          </a:fontRef>
+        </p:style>
+        <p:txBody>
+          <a:bodyPr rtlCol="0" anchor="ctr"/>
+          <a:lstStyle/>
+          <a:p>
+            <a:pPr algn="ctr"/>
+            <a:endParaRPr/>
+          </a:p>
+        </p:txBody>
+      </p:sp>
+      <p:sp>
+        <p:nvSpPr>
+          <p:cNvPr id="6" name="TextBox 5"/>
+          <p:cNvSpPr txBox="1"/>
+          <p:nvPr/>
+        </p:nvSpPr>
+        <p:spPr>
+          <a:xfrm>
+            <a:off x="228591" y="1066773"/>
+            <a:ext cx="1722076" cy="3481594"/>
+          </a:xfrm>
+          <a:prstGeom prst="rect">
+            <a:avLst/>
+          </a:prstGeom>
+          <a:noFill/>
+        </p:spPr>
+        <p:txBody>
+          <a:bodyPr wrap="square" lIns="36576" tIns="18288" rIns="36576" bIns="18288" anchor="t">
+            <a:spAutoFit/>
+          </a:bodyPr>
+          <a:lstStyle/>
+          <a:p>
+            <a:pPr algn="l">
+              <a:lnSpc>
+                <a:spcPct val="150000"/>
+              </a:lnSpc>
+              <a:spcBef>
+                <a:spcPts val="0"/>
+              </a:spcBef>
+              <a:spcAft>
+                <a:spcPts val="600"/>
+              </a:spcAft>
+            </a:pPr>
+            <a:r>
+              <a:rPr sz="1200" b="1" i="0" dirty="0">
+                <a:latin typeface="Times New Roman" panose="02020603050405020304" pitchFamily="18" charset="0"/>
+                <a:cs typeface="Times New Roman" panose="02020603050405020304" pitchFamily="18" charset="0"/>
+              </a:rPr>
+              <a:t>•  </a:t>
+            </a:r>
+            <a:r>
+              <a:rPr sz="1200" b="0" i="0" dirty="0">
+                <a:latin typeface="Times New Roman" panose="02020603050405020304" pitchFamily="18" charset="0"/>
+                <a:cs typeface="Times New Roman" panose="02020603050405020304" pitchFamily="18" charset="0"/>
+              </a:rPr>
+              <a:t>Identify accessibility barriers in blockchain healthcare interfaces for people with disabilities (</a:t>
+            </a:r>
+            <a:r>
+              <a:rPr sz="1200" b="0" i="0" dirty="0" err="1">
+                <a:latin typeface="Times New Roman" panose="02020603050405020304" pitchFamily="18" charset="0"/>
+                <a:cs typeface="Times New Roman" panose="02020603050405020304" pitchFamily="18" charset="0"/>
+              </a:rPr>
+              <a:t>PwDs</a:t>
+            </a:r>
+            <a:r>
+              <a:rPr sz="1200" b="0" i="0" dirty="0">
+                <a:latin typeface="Times New Roman" panose="02020603050405020304" pitchFamily="18" charset="0"/>
+                <a:cs typeface="Times New Roman" panose="02020603050405020304" pitchFamily="18" charset="0"/>
+              </a:rPr>
+              <a:t>).</a:t>
+            </a:r>
+          </a:p>
+          <a:p>
+            <a:pPr algn="l">
+              <a:lnSpc>
+                <a:spcPct val="150000"/>
+              </a:lnSpc>
+              <a:spcBef>
+                <a:spcPts val="0"/>
+              </a:spcBef>
+              <a:spcAft>
+                <a:spcPts val="600"/>
+              </a:spcAft>
+            </a:pPr>
+            <a:r>
+              <a:rPr sz="1200" b="1" i="0" dirty="0">
+                <a:latin typeface="Times New Roman" panose="02020603050405020304" pitchFamily="18" charset="0"/>
+                <a:cs typeface="Times New Roman" panose="02020603050405020304" pitchFamily="18" charset="0"/>
+              </a:rPr>
+              <a:t>•  </a:t>
+            </a:r>
+            <a:r>
+              <a:rPr sz="1200" b="0" i="0" dirty="0">
+                <a:latin typeface="Times New Roman" panose="02020603050405020304" pitchFamily="18" charset="0"/>
+                <a:cs typeface="Times New Roman" panose="02020603050405020304" pitchFamily="18" charset="0"/>
+              </a:rPr>
+              <a:t>Review blockchain healthcare, HCI, accessibility and assistive technology literature.</a:t>
+            </a:r>
+          </a:p>
+          <a:p>
+            <a:pPr algn="l">
+              <a:lnSpc>
+                <a:spcPct val="150000"/>
+              </a:lnSpc>
+              <a:spcBef>
+                <a:spcPts val="0"/>
+              </a:spcBef>
+              <a:spcAft>
+                <a:spcPts val="600"/>
+              </a:spcAft>
+            </a:pPr>
+            <a:r>
+              <a:rPr sz="1200" b="1" i="0" dirty="0">
+                <a:latin typeface="Times New Roman" panose="02020603050405020304" pitchFamily="18" charset="0"/>
+                <a:cs typeface="Times New Roman" panose="02020603050405020304" pitchFamily="18" charset="0"/>
+              </a:rPr>
+              <a:t>•  </a:t>
+            </a:r>
+            <a:r>
+              <a:rPr sz="1200" b="0" i="0" dirty="0">
+                <a:latin typeface="Times New Roman" panose="02020603050405020304" pitchFamily="18" charset="0"/>
+                <a:cs typeface="Times New Roman" panose="02020603050405020304" pitchFamily="18" charset="0"/>
+              </a:rPr>
+              <a:t>Define the research gap, objectives and research questions (RQ1–RQ</a:t>
+            </a:r>
+            <a:r>
+              <a:rPr lang="en-US" sz="1200" b="0" i="0" dirty="0">
+                <a:latin typeface="Times New Roman" panose="02020603050405020304" pitchFamily="18" charset="0"/>
+                <a:cs typeface="Times New Roman" panose="02020603050405020304" pitchFamily="18" charset="0"/>
+              </a:rPr>
+              <a:t>3</a:t>
+            </a:r>
+            <a:r>
+              <a:rPr sz="1200" b="0" i="0" dirty="0">
+                <a:latin typeface="Times New Roman" panose="02020603050405020304" pitchFamily="18" charset="0"/>
+                <a:cs typeface="Times New Roman" panose="02020603050405020304" pitchFamily="18" charset="0"/>
+              </a:rPr>
+              <a:t>).</a:t>
+            </a:r>
+          </a:p>
+        </p:txBody>
+      </p:sp>
+      <p:sp>
+        <p:nvSpPr>
+          <p:cNvPr id="7" name="Rounded Rectangle 6"/>
+          <p:cNvSpPr/>
+          <p:nvPr/>
+        </p:nvSpPr>
+        <p:spPr>
+          <a:xfrm>
+            <a:off x="2164025" y="114297"/>
+            <a:ext cx="1706837" cy="761980"/>
+          </a:xfrm>
+          <a:prstGeom prst="roundRect">
+            <a:avLst>
+              <a:gd name="adj" fmla="val 10000"/>
+            </a:avLst>
+          </a:prstGeom>
+          <a:solidFill>
+            <a:srgbClr val="2E7D46"/>
+          </a:solidFill>
+          <a:ln>
+            <a:noFill/>
+          </a:ln>
+          <a:effectLst/>
+        </p:spPr>
+        <p:style>
+          <a:lnRef idx="1">
+            <a:schemeClr val="accent1"/>
+          </a:lnRef>
+          <a:fillRef idx="3">
+            <a:schemeClr val="accent1"/>
+          </a:fillRef>
+          <a:effectRef idx="2">
+            <a:schemeClr val="accent1"/>
+          </a:effectRef>
+          <a:fontRef idx="minor">
+            <a:schemeClr val="lt1"/>
+          </a:fontRef>
+        </p:style>
+        <p:txBody>
+          <a:bodyPr rtlCol="0" anchor="ctr"/>
+          <a:lstStyle/>
+          <a:p>
+            <a:pPr algn="ctr"/>
+            <a:endParaRPr>
+              <a:latin typeface="Times New Roman" panose="02020603050405020304" pitchFamily="18" charset="0"/>
+              <a:cs typeface="Times New Roman" panose="02020603050405020304" pitchFamily="18" charset="0"/>
+            </a:endParaRPr>
+          </a:p>
+        </p:txBody>
+      </p:sp>
+      <p:sp>
+        <p:nvSpPr>
+          <p:cNvPr id="8" name="Oval 7"/>
+          <p:cNvSpPr/>
+          <p:nvPr/>
+        </p:nvSpPr>
+        <p:spPr>
+          <a:xfrm>
+            <a:off x="2168487" y="103519"/>
+            <a:ext cx="289552" cy="289552"/>
+          </a:xfrm>
+          <a:prstGeom prst="ellipse">
+            <a:avLst/>
+          </a:prstGeom>
+          <a:solidFill>
+            <a:srgbClr val="FFFFFF"/>
+          </a:solidFill>
+          <a:ln w="20320">
+            <a:solidFill>
+              <a:srgbClr val="2E7D46"/>
+            </a:solidFill>
+          </a:ln>
+          <a:effectLst/>
+        </p:spPr>
+        <p:style>
+          <a:lnRef idx="1">
+            <a:schemeClr val="accent1"/>
+          </a:lnRef>
+          <a:fillRef idx="3">
+            <a:schemeClr val="accent1"/>
+          </a:fillRef>
+          <a:effectRef idx="2">
+            <a:schemeClr val="accent1"/>
+          </a:effectRef>
+          <a:fontRef idx="minor">
+            <a:schemeClr val="lt1"/>
+          </a:fontRef>
+        </p:style>
+        <p:txBody>
+          <a:bodyPr wrap="square" lIns="36576" tIns="18288" rIns="36576" bIns="18288" rtlCol="0" anchor="ctr"/>
+          <a:lstStyle/>
+          <a:p>
+            <a:pPr algn="ctr">
+              <a:spcBef>
+                <a:spcPts val="0"/>
+              </a:spcBef>
+              <a:spcAft>
+                <a:spcPts val="0"/>
+              </a:spcAft>
+            </a:pPr>
+            <a:r>
+              <a:rPr sz="1100" b="1" i="0" dirty="0">
+                <a:solidFill>
+                  <a:srgbClr val="2E7D46"/>
+                </a:solidFill>
+                <a:latin typeface="Times New Roman" panose="02020603050405020304" pitchFamily="18" charset="0"/>
+                <a:cs typeface="Times New Roman" panose="02020603050405020304" pitchFamily="18" charset="0"/>
+              </a:rPr>
+              <a:t>2</a:t>
+            </a:r>
+          </a:p>
+        </p:txBody>
+      </p:sp>
+      <p:sp>
+        <p:nvSpPr>
+          <p:cNvPr id="9" name="TextBox 8"/>
+          <p:cNvSpPr txBox="1"/>
+          <p:nvPr/>
+        </p:nvSpPr>
+        <p:spPr>
+          <a:xfrm>
+            <a:off x="2212354" y="402515"/>
+            <a:ext cx="1623546" cy="406265"/>
+          </a:xfrm>
+          <a:prstGeom prst="rect">
+            <a:avLst/>
+          </a:prstGeom>
+          <a:noFill/>
+        </p:spPr>
+        <p:txBody>
+          <a:bodyPr wrap="square" lIns="36576" tIns="18288" rIns="36576" bIns="18288" anchor="ctr">
+            <a:spAutoFit/>
+          </a:bodyPr>
+          <a:lstStyle/>
+          <a:p>
+            <a:pPr algn="l">
+              <a:spcBef>
+                <a:spcPts val="0"/>
+              </a:spcBef>
+              <a:spcAft>
+                <a:spcPts val="200"/>
+              </a:spcAft>
+            </a:pPr>
+            <a:r>
+              <a:rPr sz="1200" b="1" i="0" dirty="0">
+                <a:solidFill>
+                  <a:srgbClr val="FFFFFF"/>
+                </a:solidFill>
+                <a:latin typeface="Times New Roman" panose="02020603050405020304" pitchFamily="18" charset="0"/>
+                <a:cs typeface="Times New Roman" panose="02020603050405020304" pitchFamily="18" charset="0"/>
+              </a:rPr>
+              <a:t>OBJECTIVES OF A SOLUTION (DESIGN)</a:t>
+            </a:r>
+          </a:p>
+        </p:txBody>
+      </p:sp>
+      <p:sp>
+        <p:nvSpPr>
+          <p:cNvPr id="10" name="Rounded Rectangle 9"/>
+          <p:cNvSpPr/>
+          <p:nvPr/>
+        </p:nvSpPr>
+        <p:spPr>
+          <a:xfrm>
+            <a:off x="2164025" y="939775"/>
+            <a:ext cx="1706837" cy="3830225"/>
+          </a:xfrm>
+          <a:prstGeom prst="roundRect">
+            <a:avLst>
+              <a:gd name="adj" fmla="val 5000"/>
+            </a:avLst>
+          </a:prstGeom>
+          <a:solidFill>
+            <a:srgbClr val="FFFFFF"/>
+          </a:solidFill>
+          <a:ln w="19050">
+            <a:solidFill>
+              <a:srgbClr val="0B6A3A"/>
+            </a:solidFill>
+          </a:ln>
+        </p:spPr>
+        <p:style>
+          <a:lnRef idx="1">
+            <a:schemeClr val="accent1"/>
+          </a:lnRef>
+          <a:fillRef idx="3">
+            <a:schemeClr val="accent1"/>
+          </a:fillRef>
+          <a:effectRef idx="2">
+            <a:schemeClr val="accent1"/>
+          </a:effectRef>
+          <a:fontRef idx="minor">
+            <a:schemeClr val="lt1"/>
+          </a:fontRef>
+        </p:style>
+        <p:txBody>
+          <a:bodyPr rtlCol="0" anchor="ctr"/>
+          <a:lstStyle/>
+          <a:p>
+            <a:pPr algn="ctr"/>
+            <a:endParaRPr/>
+          </a:p>
+        </p:txBody>
+      </p:sp>
+      <p:sp>
+        <p:nvSpPr>
+          <p:cNvPr id="11" name="TextBox 10"/>
+          <p:cNvSpPr txBox="1"/>
+          <p:nvPr/>
+        </p:nvSpPr>
+        <p:spPr>
+          <a:xfrm>
+            <a:off x="2285942" y="1066773"/>
+            <a:ext cx="1478243" cy="3758593"/>
+          </a:xfrm>
+          <a:prstGeom prst="rect">
+            <a:avLst/>
+          </a:prstGeom>
+          <a:noFill/>
+        </p:spPr>
+        <p:txBody>
+          <a:bodyPr wrap="square" lIns="36576" tIns="18288" rIns="36576" bIns="18288" anchor="t">
+            <a:spAutoFit/>
+          </a:bodyPr>
+          <a:lstStyle/>
+          <a:p>
+            <a:pPr algn="l">
+              <a:lnSpc>
+                <a:spcPct val="150000"/>
+              </a:lnSpc>
+              <a:spcBef>
+                <a:spcPts val="0"/>
+              </a:spcBef>
+              <a:spcAft>
+                <a:spcPts val="600"/>
+              </a:spcAft>
+            </a:pPr>
+            <a:r>
+              <a:rPr sz="1200" b="1" i="0" dirty="0">
+                <a:latin typeface="Times New Roman" panose="02020603050405020304" pitchFamily="18" charset="0"/>
+                <a:cs typeface="Times New Roman" panose="02020603050405020304" pitchFamily="18" charset="0"/>
+              </a:rPr>
+              <a:t>•  </a:t>
+            </a:r>
+            <a:r>
+              <a:rPr sz="1200" b="0" i="0" dirty="0">
+                <a:latin typeface="Times New Roman" panose="02020603050405020304" pitchFamily="18" charset="0"/>
+                <a:cs typeface="Times New Roman" panose="02020603050405020304" pitchFamily="18" charset="0"/>
+              </a:rPr>
+              <a:t>Derive accessibility requirements and HCI design principles (AAD, PTD, CID and UAC).</a:t>
+            </a:r>
+          </a:p>
+          <a:p>
+            <a:pPr algn="l">
+              <a:lnSpc>
+                <a:spcPct val="150000"/>
+              </a:lnSpc>
+              <a:spcBef>
+                <a:spcPts val="0"/>
+              </a:spcBef>
+              <a:spcAft>
+                <a:spcPts val="600"/>
+              </a:spcAft>
+            </a:pPr>
+            <a:r>
+              <a:rPr sz="1200" b="1" i="0" dirty="0">
+                <a:latin typeface="Times New Roman" panose="02020603050405020304" pitchFamily="18" charset="0"/>
+                <a:cs typeface="Times New Roman" panose="02020603050405020304" pitchFamily="18" charset="0"/>
+              </a:rPr>
+              <a:t>•  </a:t>
+            </a:r>
+            <a:r>
+              <a:rPr sz="1200" b="0" i="0" dirty="0">
+                <a:latin typeface="Times New Roman" panose="02020603050405020304" pitchFamily="18" charset="0"/>
+                <a:cs typeface="Times New Roman" panose="02020603050405020304" pitchFamily="18" charset="0"/>
+              </a:rPr>
+              <a:t>Develop the BCHAIN-ACCESS framework with four integrated perspectives.</a:t>
+            </a:r>
+          </a:p>
+          <a:p>
+            <a:pPr algn="l">
+              <a:lnSpc>
+                <a:spcPct val="150000"/>
+              </a:lnSpc>
+              <a:spcBef>
+                <a:spcPts val="0"/>
+              </a:spcBef>
+              <a:spcAft>
+                <a:spcPts val="600"/>
+              </a:spcAft>
+            </a:pPr>
+            <a:r>
+              <a:rPr sz="1200" b="1" i="0" dirty="0">
+                <a:latin typeface="Times New Roman" panose="02020603050405020304" pitchFamily="18" charset="0"/>
+                <a:cs typeface="Times New Roman" panose="02020603050405020304" pitchFamily="18" charset="0"/>
+              </a:rPr>
+              <a:t>•  </a:t>
+            </a:r>
+            <a:r>
+              <a:rPr sz="1200" b="0" i="0" dirty="0">
+                <a:latin typeface="Times New Roman" panose="02020603050405020304" pitchFamily="18" charset="0"/>
+                <a:cs typeface="Times New Roman" panose="02020603050405020304" pitchFamily="18" charset="0"/>
+              </a:rPr>
+              <a:t>Define the system architecture and design specifications.</a:t>
+            </a:r>
+          </a:p>
+        </p:txBody>
+      </p:sp>
+      <p:sp>
+        <p:nvSpPr>
+          <p:cNvPr id="12" name="Rounded Rectangle 11"/>
+          <p:cNvSpPr/>
+          <p:nvPr/>
+        </p:nvSpPr>
+        <p:spPr>
+          <a:xfrm>
+            <a:off x="4099457" y="114297"/>
+            <a:ext cx="1706837" cy="761980"/>
+          </a:xfrm>
+          <a:prstGeom prst="roundRect">
+            <a:avLst>
+              <a:gd name="adj" fmla="val 10000"/>
+            </a:avLst>
+          </a:prstGeom>
+          <a:solidFill>
+            <a:srgbClr val="5E1F8C"/>
+          </a:solidFill>
+          <a:ln>
+            <a:noFill/>
+          </a:ln>
+        </p:spPr>
+        <p:style>
+          <a:lnRef idx="1">
+            <a:schemeClr val="accent1"/>
+          </a:lnRef>
+          <a:fillRef idx="3">
+            <a:schemeClr val="accent1"/>
+          </a:fillRef>
+          <a:effectRef idx="2">
+            <a:schemeClr val="accent1"/>
+          </a:effectRef>
+          <a:fontRef idx="minor">
+            <a:schemeClr val="lt1"/>
+          </a:fontRef>
+        </p:style>
+        <p:txBody>
+          <a:bodyPr rtlCol="0" anchor="ctr"/>
+          <a:lstStyle/>
+          <a:p>
+            <a:pPr algn="ctr"/>
+            <a:endParaRPr/>
+          </a:p>
+        </p:txBody>
+      </p:sp>
+      <p:sp>
+        <p:nvSpPr>
+          <p:cNvPr id="13" name="Oval 12"/>
+          <p:cNvSpPr/>
+          <p:nvPr/>
+        </p:nvSpPr>
+        <p:spPr>
+          <a:xfrm>
+            <a:off x="4103919" y="103519"/>
+            <a:ext cx="289552" cy="289552"/>
+          </a:xfrm>
+          <a:prstGeom prst="ellipse">
+            <a:avLst/>
+          </a:prstGeom>
+          <a:solidFill>
+            <a:srgbClr val="FFFFFF"/>
+          </a:solidFill>
+          <a:ln w="20320">
+            <a:solidFill>
+              <a:srgbClr val="6A2C91"/>
+            </a:solidFill>
+          </a:ln>
+          <a:effectLst/>
+        </p:spPr>
+        <p:style>
+          <a:lnRef idx="1">
+            <a:schemeClr val="accent1"/>
+          </a:lnRef>
+          <a:fillRef idx="3">
+            <a:schemeClr val="accent1"/>
+          </a:fillRef>
+          <a:effectRef idx="2">
+            <a:schemeClr val="accent1"/>
+          </a:effectRef>
+          <a:fontRef idx="minor">
+            <a:schemeClr val="lt1"/>
+          </a:fontRef>
+        </p:style>
+        <p:txBody>
+          <a:bodyPr wrap="square" lIns="36576" tIns="18288" rIns="36576" bIns="18288" rtlCol="0" anchor="ctr"/>
+          <a:lstStyle/>
+          <a:p>
+            <a:pPr algn="ctr">
+              <a:spcBef>
+                <a:spcPts val="0"/>
+              </a:spcBef>
+              <a:spcAft>
+                <a:spcPts val="0"/>
+              </a:spcAft>
+            </a:pPr>
+            <a:r>
+              <a:rPr sz="1100" b="1" i="0" dirty="0">
+                <a:solidFill>
+                  <a:srgbClr val="6A2C91"/>
+                </a:solidFill>
+                <a:latin typeface="Times New Roman" panose="02020603050405020304" pitchFamily="18" charset="0"/>
+                <a:cs typeface="Times New Roman" panose="02020603050405020304" pitchFamily="18" charset="0"/>
+              </a:rPr>
+              <a:t>3</a:t>
+            </a:r>
+          </a:p>
+        </p:txBody>
+      </p:sp>
+      <p:sp>
+        <p:nvSpPr>
+          <p:cNvPr id="14" name="TextBox 13"/>
+          <p:cNvSpPr txBox="1"/>
+          <p:nvPr/>
+        </p:nvSpPr>
+        <p:spPr>
+          <a:xfrm>
+            <a:off x="4155677" y="402516"/>
+            <a:ext cx="1612518" cy="406265"/>
+          </a:xfrm>
+          <a:prstGeom prst="rect">
+            <a:avLst/>
+          </a:prstGeom>
+          <a:noFill/>
+        </p:spPr>
+        <p:txBody>
+          <a:bodyPr wrap="square" lIns="36576" tIns="18288" rIns="36576" bIns="18288" anchor="ctr">
+            <a:spAutoFit/>
+          </a:bodyPr>
+          <a:lstStyle/>
+          <a:p>
+            <a:pPr algn="l">
+              <a:spcBef>
+                <a:spcPts val="0"/>
+              </a:spcBef>
+              <a:spcAft>
+                <a:spcPts val="200"/>
+              </a:spcAft>
+            </a:pPr>
+            <a:r>
+              <a:rPr sz="1200" b="1" i="0" dirty="0">
+                <a:solidFill>
+                  <a:srgbClr val="FFFFFF"/>
+                </a:solidFill>
+                <a:latin typeface="Times New Roman" panose="02020603050405020304" pitchFamily="18" charset="0"/>
+                <a:cs typeface="Times New Roman" panose="02020603050405020304" pitchFamily="18" charset="0"/>
+              </a:rPr>
+              <a:t>DESIGN AND DEVELOPMENT</a:t>
+            </a:r>
+          </a:p>
+        </p:txBody>
+      </p:sp>
+      <p:sp>
+        <p:nvSpPr>
+          <p:cNvPr id="15" name="Rounded Rectangle 14"/>
+          <p:cNvSpPr/>
+          <p:nvPr/>
+        </p:nvSpPr>
+        <p:spPr>
+          <a:xfrm>
+            <a:off x="4099457" y="965174"/>
+            <a:ext cx="1706837" cy="3820864"/>
+          </a:xfrm>
+          <a:prstGeom prst="roundRect">
+            <a:avLst>
+              <a:gd name="adj" fmla="val 5000"/>
+            </a:avLst>
+          </a:prstGeom>
+          <a:solidFill>
+            <a:srgbClr val="FFFFFF"/>
+          </a:solidFill>
+          <a:ln w="19050">
+            <a:solidFill>
+              <a:srgbClr val="5E1F8C"/>
+            </a:solidFill>
+          </a:ln>
+        </p:spPr>
+        <p:style>
+          <a:lnRef idx="1">
+            <a:schemeClr val="accent1"/>
+          </a:lnRef>
+          <a:fillRef idx="3">
+            <a:schemeClr val="accent1"/>
+          </a:fillRef>
+          <a:effectRef idx="2">
+            <a:schemeClr val="accent1"/>
+          </a:effectRef>
+          <a:fontRef idx="minor">
+            <a:schemeClr val="lt1"/>
+          </a:fontRef>
+        </p:style>
+        <p:txBody>
+          <a:bodyPr rtlCol="0" anchor="ctr"/>
+          <a:lstStyle/>
+          <a:p>
+            <a:pPr algn="ctr"/>
+            <a:endParaRPr/>
+          </a:p>
+        </p:txBody>
+      </p:sp>
+      <p:sp>
+        <p:nvSpPr>
+          <p:cNvPr id="16" name="TextBox 15"/>
+          <p:cNvSpPr txBox="1"/>
+          <p:nvPr/>
+        </p:nvSpPr>
+        <p:spPr>
+          <a:xfrm>
+            <a:off x="4221374" y="1066773"/>
+            <a:ext cx="1546821" cy="2650597"/>
+          </a:xfrm>
+          <a:prstGeom prst="rect">
+            <a:avLst/>
+          </a:prstGeom>
+          <a:noFill/>
+        </p:spPr>
+        <p:txBody>
+          <a:bodyPr wrap="square" lIns="36576" tIns="18288" rIns="36576" bIns="18288" anchor="t">
+            <a:spAutoFit/>
+          </a:bodyPr>
+          <a:lstStyle/>
+          <a:p>
+            <a:pPr algn="l">
+              <a:lnSpc>
+                <a:spcPct val="150000"/>
+              </a:lnSpc>
+              <a:spcBef>
+                <a:spcPts val="0"/>
+              </a:spcBef>
+              <a:spcAft>
+                <a:spcPts val="600"/>
+              </a:spcAft>
+            </a:pPr>
+            <a:r>
+              <a:rPr sz="1200" b="1" i="0" dirty="0">
+                <a:latin typeface="Times New Roman" panose="02020603050405020304" pitchFamily="18" charset="0"/>
+                <a:cs typeface="Times New Roman" panose="02020603050405020304" pitchFamily="18" charset="0"/>
+              </a:rPr>
+              <a:t>•  </a:t>
+            </a:r>
+            <a:r>
+              <a:rPr sz="1200" b="0" i="0" dirty="0">
+                <a:latin typeface="Times New Roman" panose="02020603050405020304" pitchFamily="18" charset="0"/>
+                <a:cs typeface="Times New Roman" panose="02020603050405020304" pitchFamily="18" charset="0"/>
+              </a:rPr>
+              <a:t>Develop the BCHAIN-ACCESS reference prototype.</a:t>
+            </a:r>
+          </a:p>
+          <a:p>
+            <a:pPr algn="l">
+              <a:lnSpc>
+                <a:spcPct val="150000"/>
+              </a:lnSpc>
+              <a:spcBef>
+                <a:spcPts val="0"/>
+              </a:spcBef>
+              <a:spcAft>
+                <a:spcPts val="600"/>
+              </a:spcAft>
+            </a:pPr>
+            <a:r>
+              <a:rPr sz="1200" b="1" i="0" dirty="0">
+                <a:latin typeface="Times New Roman" panose="02020603050405020304" pitchFamily="18" charset="0"/>
+                <a:cs typeface="Times New Roman" panose="02020603050405020304" pitchFamily="18" charset="0"/>
+              </a:rPr>
+              <a:t>•  </a:t>
+            </a:r>
+            <a:r>
+              <a:rPr sz="1200" b="0" i="0" dirty="0">
+                <a:latin typeface="Times New Roman" panose="02020603050405020304" pitchFamily="18" charset="0"/>
+                <a:cs typeface="Times New Roman" panose="02020603050405020304" pitchFamily="18" charset="0"/>
+              </a:rPr>
+              <a:t>Implement the four-layer system architecture.</a:t>
+            </a:r>
+          </a:p>
+          <a:p>
+            <a:pPr algn="l">
+              <a:lnSpc>
+                <a:spcPct val="150000"/>
+              </a:lnSpc>
+              <a:spcBef>
+                <a:spcPts val="0"/>
+              </a:spcBef>
+              <a:spcAft>
+                <a:spcPts val="600"/>
+              </a:spcAft>
+            </a:pPr>
+            <a:r>
+              <a:rPr sz="1200" b="1" i="0" dirty="0">
+                <a:latin typeface="Times New Roman" panose="02020603050405020304" pitchFamily="18" charset="0"/>
+                <a:cs typeface="Times New Roman" panose="02020603050405020304" pitchFamily="18" charset="0"/>
+              </a:rPr>
+              <a:t>•  </a:t>
+            </a:r>
+            <a:r>
+              <a:rPr sz="1200" b="0" i="0" dirty="0">
+                <a:latin typeface="Times New Roman" panose="02020603050405020304" pitchFamily="18" charset="0"/>
+                <a:cs typeface="Times New Roman" panose="02020603050405020304" pitchFamily="18" charset="0"/>
+              </a:rPr>
+              <a:t>Integrate accessibility features and inclusive user interfaces.</a:t>
+            </a:r>
+          </a:p>
+        </p:txBody>
+      </p:sp>
+      <p:sp>
+        <p:nvSpPr>
+          <p:cNvPr id="17" name="Rounded Rectangle 16"/>
+          <p:cNvSpPr/>
+          <p:nvPr/>
+        </p:nvSpPr>
+        <p:spPr>
+          <a:xfrm>
+            <a:off x="6034889" y="114297"/>
+            <a:ext cx="1706837" cy="761980"/>
+          </a:xfrm>
+          <a:prstGeom prst="roundRect">
+            <a:avLst>
+              <a:gd name="adj" fmla="val 10000"/>
+            </a:avLst>
+          </a:prstGeom>
+          <a:solidFill>
+            <a:srgbClr val="00695C"/>
+          </a:solidFill>
+          <a:ln>
+            <a:noFill/>
+          </a:ln>
+        </p:spPr>
+        <p:style>
+          <a:lnRef idx="1">
+            <a:schemeClr val="accent1"/>
+          </a:lnRef>
+          <a:fillRef idx="3">
+            <a:schemeClr val="accent1"/>
+          </a:fillRef>
+          <a:effectRef idx="2">
+            <a:schemeClr val="accent1"/>
+          </a:effectRef>
+          <a:fontRef idx="minor">
+            <a:schemeClr val="lt1"/>
+          </a:fontRef>
+        </p:style>
+        <p:txBody>
+          <a:bodyPr rtlCol="0" anchor="ctr"/>
+          <a:lstStyle/>
+          <a:p>
+            <a:pPr algn="ctr"/>
+            <a:endParaRPr/>
+          </a:p>
+        </p:txBody>
+      </p:sp>
+      <p:sp>
+        <p:nvSpPr>
+          <p:cNvPr id="18" name="Oval 17"/>
+          <p:cNvSpPr/>
+          <p:nvPr/>
+        </p:nvSpPr>
+        <p:spPr>
+          <a:xfrm>
+            <a:off x="6055116" y="103519"/>
+            <a:ext cx="289552" cy="289552"/>
+          </a:xfrm>
+          <a:prstGeom prst="ellipse">
+            <a:avLst/>
+          </a:prstGeom>
+          <a:solidFill>
+            <a:srgbClr val="FFFFFF"/>
+          </a:solidFill>
+          <a:ln w="20320">
+            <a:solidFill>
+              <a:srgbClr val="1F7A8C"/>
+            </a:solidFill>
+          </a:ln>
+          <a:effectLst/>
+        </p:spPr>
+        <p:style>
+          <a:lnRef idx="1">
+            <a:schemeClr val="accent1"/>
+          </a:lnRef>
+          <a:fillRef idx="3">
+            <a:schemeClr val="accent1"/>
+          </a:fillRef>
+          <a:effectRef idx="2">
+            <a:schemeClr val="accent1"/>
+          </a:effectRef>
+          <a:fontRef idx="minor">
+            <a:schemeClr val="lt1"/>
+          </a:fontRef>
+        </p:style>
+        <p:txBody>
+          <a:bodyPr wrap="square" lIns="36576" tIns="18288" rIns="36576" bIns="18288" rtlCol="0" anchor="ctr"/>
+          <a:lstStyle/>
+          <a:p>
+            <a:pPr algn="ctr">
+              <a:spcBef>
+                <a:spcPts val="0"/>
+              </a:spcBef>
+              <a:spcAft>
+                <a:spcPts val="0"/>
+              </a:spcAft>
+            </a:pPr>
+            <a:r>
+              <a:rPr sz="1100" b="1" i="0" dirty="0">
+                <a:solidFill>
+                  <a:srgbClr val="1F7A8C"/>
+                </a:solidFill>
+                <a:latin typeface="Times New Roman" panose="02020603050405020304" pitchFamily="18" charset="0"/>
+                <a:cs typeface="Times New Roman" panose="02020603050405020304" pitchFamily="18" charset="0"/>
+              </a:rPr>
+              <a:t>4</a:t>
+            </a:r>
+          </a:p>
+        </p:txBody>
+      </p:sp>
+      <p:sp>
+        <p:nvSpPr>
+          <p:cNvPr id="19" name="TextBox 18"/>
+          <p:cNvSpPr txBox="1"/>
+          <p:nvPr/>
+        </p:nvSpPr>
+        <p:spPr>
+          <a:xfrm>
+            <a:off x="6083216" y="510614"/>
+            <a:ext cx="1496642" cy="221599"/>
+          </a:xfrm>
+          <a:prstGeom prst="rect">
+            <a:avLst/>
+          </a:prstGeom>
+          <a:noFill/>
+        </p:spPr>
+        <p:txBody>
+          <a:bodyPr wrap="square" lIns="36576" tIns="18288" rIns="36576" bIns="18288" anchor="ctr">
+            <a:spAutoFit/>
+          </a:bodyPr>
+          <a:lstStyle/>
+          <a:p>
+            <a:pPr algn="l">
+              <a:spcBef>
+                <a:spcPts val="0"/>
+              </a:spcBef>
+              <a:spcAft>
+                <a:spcPts val="200"/>
+              </a:spcAft>
+            </a:pPr>
+            <a:r>
+              <a:rPr lang="en-US" sz="1200" b="1" dirty="0">
+                <a:solidFill>
+                  <a:schemeClr val="bg1"/>
+                </a:solidFill>
+                <a:latin typeface="Times New Roman" panose="02020603050405020304" pitchFamily="18" charset="0"/>
+                <a:cs typeface="Times New Roman" panose="02020603050405020304" pitchFamily="18" charset="0"/>
+              </a:rPr>
+              <a:t>DEMONSTRATION</a:t>
+            </a:r>
+            <a:endParaRPr sz="1600" b="1" i="0" dirty="0">
+              <a:solidFill>
+                <a:schemeClr val="bg1"/>
+              </a:solidFill>
+              <a:latin typeface="Times New Roman" panose="02020603050405020304" pitchFamily="18" charset="0"/>
+              <a:cs typeface="Times New Roman" panose="02020603050405020304" pitchFamily="18" charset="0"/>
+            </a:endParaRPr>
+          </a:p>
+        </p:txBody>
+      </p:sp>
+      <p:sp>
+        <p:nvSpPr>
+          <p:cNvPr id="20" name="Rounded Rectangle 19"/>
+          <p:cNvSpPr/>
+          <p:nvPr/>
+        </p:nvSpPr>
+        <p:spPr>
+          <a:xfrm>
+            <a:off x="6034889" y="965176"/>
+            <a:ext cx="1706837" cy="3774373"/>
+          </a:xfrm>
+          <a:prstGeom prst="roundRect">
+            <a:avLst>
+              <a:gd name="adj" fmla="val 5000"/>
+            </a:avLst>
+          </a:prstGeom>
+          <a:solidFill>
+            <a:srgbClr val="FFFFFF"/>
+          </a:solidFill>
+          <a:ln w="19050">
+            <a:solidFill>
+              <a:srgbClr val="00695C"/>
+            </a:solidFill>
+          </a:ln>
+        </p:spPr>
+        <p:style>
+          <a:lnRef idx="1">
+            <a:schemeClr val="accent1"/>
+          </a:lnRef>
+          <a:fillRef idx="3">
+            <a:schemeClr val="accent1"/>
+          </a:fillRef>
+          <a:effectRef idx="2">
+            <a:schemeClr val="accent1"/>
+          </a:effectRef>
+          <a:fontRef idx="minor">
+            <a:schemeClr val="lt1"/>
+          </a:fontRef>
+        </p:style>
+        <p:txBody>
+          <a:bodyPr rtlCol="0" anchor="ctr"/>
+          <a:lstStyle/>
+          <a:p>
+            <a:pPr algn="ctr"/>
+            <a:endParaRPr/>
+          </a:p>
+        </p:txBody>
+      </p:sp>
+      <p:sp>
+        <p:nvSpPr>
+          <p:cNvPr id="21" name="TextBox 20"/>
+          <p:cNvSpPr txBox="1"/>
+          <p:nvPr/>
+        </p:nvSpPr>
+        <p:spPr>
+          <a:xfrm>
+            <a:off x="6052484" y="977074"/>
+            <a:ext cx="1668737" cy="3758593"/>
+          </a:xfrm>
+          <a:prstGeom prst="rect">
+            <a:avLst/>
+          </a:prstGeom>
+          <a:noFill/>
+        </p:spPr>
+        <p:txBody>
+          <a:bodyPr wrap="square" lIns="36576" tIns="18288" rIns="36576" bIns="18288" anchor="t">
+            <a:spAutoFit/>
+          </a:bodyPr>
+          <a:lstStyle/>
+          <a:p>
+            <a:pPr algn="l">
+              <a:lnSpc>
+                <a:spcPct val="150000"/>
+              </a:lnSpc>
+              <a:spcBef>
+                <a:spcPts val="0"/>
+              </a:spcBef>
+              <a:spcAft>
+                <a:spcPts val="600"/>
+              </a:spcAft>
+            </a:pPr>
+            <a:r>
+              <a:rPr sz="1200" b="1" i="0" dirty="0">
+                <a:latin typeface="Times New Roman" panose="02020603050405020304" pitchFamily="18" charset="0"/>
+                <a:cs typeface="Times New Roman" panose="02020603050405020304" pitchFamily="18" charset="0"/>
+              </a:rPr>
+              <a:t>•  </a:t>
+            </a:r>
+            <a:r>
+              <a:rPr sz="1200" b="0" i="0" dirty="0">
+                <a:latin typeface="Times New Roman" panose="02020603050405020304" pitchFamily="18" charset="0"/>
+                <a:cs typeface="Times New Roman" panose="02020603050405020304" pitchFamily="18" charset="0"/>
+              </a:rPr>
+              <a:t>Perform automated accessibility evaluation using Lighthouse, WAVE, and Axe </a:t>
+            </a:r>
+            <a:r>
+              <a:rPr sz="1200" b="0" i="0" dirty="0" err="1">
+                <a:latin typeface="Times New Roman" panose="02020603050405020304" pitchFamily="18" charset="0"/>
+                <a:cs typeface="Times New Roman" panose="02020603050405020304" pitchFamily="18" charset="0"/>
+              </a:rPr>
+              <a:t>DevTools</a:t>
+            </a:r>
+            <a:r>
+              <a:rPr sz="1200" b="0" i="0" dirty="0">
+                <a:latin typeface="Times New Roman" panose="02020603050405020304" pitchFamily="18" charset="0"/>
+                <a:cs typeface="Times New Roman" panose="02020603050405020304" pitchFamily="18" charset="0"/>
+              </a:rPr>
+              <a:t>.</a:t>
+            </a:r>
+          </a:p>
+          <a:p>
+            <a:pPr algn="l">
+              <a:lnSpc>
+                <a:spcPct val="150000"/>
+              </a:lnSpc>
+              <a:spcBef>
+                <a:spcPts val="0"/>
+              </a:spcBef>
+              <a:spcAft>
+                <a:spcPts val="600"/>
+              </a:spcAft>
+            </a:pPr>
+            <a:r>
+              <a:rPr sz="1200" b="1" i="0" dirty="0">
+                <a:latin typeface="Times New Roman" panose="02020603050405020304" pitchFamily="18" charset="0"/>
+                <a:cs typeface="Times New Roman" panose="02020603050405020304" pitchFamily="18" charset="0"/>
+              </a:rPr>
+              <a:t>•  </a:t>
+            </a:r>
+            <a:r>
+              <a:rPr sz="1200" b="0" i="0" dirty="0">
+                <a:latin typeface="Times New Roman" panose="02020603050405020304" pitchFamily="18" charset="0"/>
+                <a:cs typeface="Times New Roman" panose="02020603050405020304" pitchFamily="18" charset="0"/>
+              </a:rPr>
+              <a:t>Conduct expert</a:t>
+            </a:r>
+            <a:r>
+              <a:rPr lang="en-US" sz="1200" b="0" i="0" dirty="0">
+                <a:latin typeface="Times New Roman" panose="02020603050405020304" pitchFamily="18" charset="0"/>
+                <a:cs typeface="Times New Roman" panose="02020603050405020304" pitchFamily="18" charset="0"/>
+              </a:rPr>
+              <a:t> </a:t>
+            </a:r>
+            <a:r>
+              <a:rPr sz="1200" b="0" i="0" dirty="0">
+                <a:latin typeface="Times New Roman" panose="02020603050405020304" pitchFamily="18" charset="0"/>
+                <a:cs typeface="Times New Roman" panose="02020603050405020304" pitchFamily="18" charset="0"/>
+              </a:rPr>
+              <a:t>evaluation using heuristic evaluation, cognitive walkthrough, SUS</a:t>
+            </a:r>
+            <a:r>
+              <a:rPr lang="en-US" sz="1200" dirty="0">
+                <a:latin typeface="Times New Roman" panose="02020603050405020304" pitchFamily="18" charset="0"/>
+                <a:cs typeface="Times New Roman" panose="02020603050405020304" pitchFamily="18" charset="0"/>
+              </a:rPr>
+              <a:t> </a:t>
+            </a:r>
+            <a:r>
+              <a:rPr sz="1200" b="0" i="0" dirty="0">
+                <a:latin typeface="Times New Roman" panose="02020603050405020304" pitchFamily="18" charset="0"/>
+                <a:cs typeface="Times New Roman" panose="02020603050405020304" pitchFamily="18" charset="0"/>
+              </a:rPr>
+              <a:t>and an accessibility questionnaire (N = 10).</a:t>
+            </a:r>
+          </a:p>
+          <a:p>
+            <a:pPr algn="l">
+              <a:lnSpc>
+                <a:spcPct val="150000"/>
+              </a:lnSpc>
+              <a:spcBef>
+                <a:spcPts val="0"/>
+              </a:spcBef>
+              <a:spcAft>
+                <a:spcPts val="600"/>
+              </a:spcAft>
+            </a:pPr>
+            <a:r>
+              <a:rPr sz="1200" b="1" i="0" dirty="0">
+                <a:latin typeface="Times New Roman" panose="02020603050405020304" pitchFamily="18" charset="0"/>
+                <a:cs typeface="Times New Roman" panose="02020603050405020304" pitchFamily="18" charset="0"/>
+              </a:rPr>
+              <a:t>•  </a:t>
+            </a:r>
+            <a:r>
+              <a:rPr sz="1200" b="0" i="0" dirty="0">
+                <a:latin typeface="Times New Roman" panose="02020603050405020304" pitchFamily="18" charset="0"/>
+                <a:cs typeface="Times New Roman" panose="02020603050405020304" pitchFamily="18" charset="0"/>
+              </a:rPr>
+              <a:t>Analyze results and validate the proposed framework.</a:t>
+            </a:r>
+          </a:p>
+        </p:txBody>
+      </p:sp>
+      <p:sp>
+        <p:nvSpPr>
+          <p:cNvPr id="22" name="Rounded Rectangle 21"/>
+          <p:cNvSpPr/>
+          <p:nvPr/>
+        </p:nvSpPr>
+        <p:spPr>
+          <a:xfrm>
+            <a:off x="7970320" y="114297"/>
+            <a:ext cx="1706837" cy="761980"/>
+          </a:xfrm>
+          <a:prstGeom prst="roundRect">
+            <a:avLst>
+              <a:gd name="adj" fmla="val 10000"/>
+            </a:avLst>
+          </a:prstGeom>
+          <a:solidFill>
+            <a:srgbClr val="D86B00"/>
+          </a:solidFill>
+          <a:ln>
+            <a:noFill/>
+          </a:ln>
+        </p:spPr>
+        <p:style>
+          <a:lnRef idx="1">
+            <a:schemeClr val="accent1"/>
+          </a:lnRef>
+          <a:fillRef idx="3">
+            <a:schemeClr val="accent1"/>
+          </a:fillRef>
+          <a:effectRef idx="2">
+            <a:schemeClr val="accent1"/>
+          </a:effectRef>
+          <a:fontRef idx="minor">
+            <a:schemeClr val="lt1"/>
+          </a:fontRef>
+        </p:style>
+        <p:txBody>
+          <a:bodyPr rtlCol="0" anchor="ctr"/>
+          <a:lstStyle/>
+          <a:p>
+            <a:pPr algn="ctr"/>
+            <a:endParaRPr/>
+          </a:p>
+        </p:txBody>
+      </p:sp>
+      <p:sp>
+        <p:nvSpPr>
+          <p:cNvPr id="23" name="Oval 22"/>
+          <p:cNvSpPr/>
+          <p:nvPr/>
+        </p:nvSpPr>
+        <p:spPr>
+          <a:xfrm>
+            <a:off x="8022080" y="87753"/>
+            <a:ext cx="289552" cy="289552"/>
+          </a:xfrm>
+          <a:prstGeom prst="ellipse">
+            <a:avLst/>
+          </a:prstGeom>
+          <a:solidFill>
+            <a:srgbClr val="FFFFFF"/>
+          </a:solidFill>
+          <a:ln w="20320">
+            <a:solidFill>
+              <a:srgbClr val="B5651D"/>
+            </a:solidFill>
+          </a:ln>
+          <a:effectLst/>
+        </p:spPr>
+        <p:style>
+          <a:lnRef idx="1">
+            <a:schemeClr val="accent1"/>
+          </a:lnRef>
+          <a:fillRef idx="3">
+            <a:schemeClr val="accent1"/>
+          </a:fillRef>
+          <a:effectRef idx="2">
+            <a:schemeClr val="accent1"/>
+          </a:effectRef>
+          <a:fontRef idx="minor">
+            <a:schemeClr val="lt1"/>
+          </a:fontRef>
+        </p:style>
+        <p:txBody>
+          <a:bodyPr wrap="square" lIns="36576" tIns="18288" rIns="36576" bIns="18288" rtlCol="0" anchor="ctr"/>
+          <a:lstStyle/>
+          <a:p>
+            <a:pPr algn="ctr">
+              <a:spcBef>
+                <a:spcPts val="0"/>
+              </a:spcBef>
+              <a:spcAft>
+                <a:spcPts val="0"/>
+              </a:spcAft>
+            </a:pPr>
+            <a:r>
+              <a:rPr sz="1100" b="1" i="0" dirty="0">
+                <a:solidFill>
+                  <a:srgbClr val="B5651D"/>
+                </a:solidFill>
+                <a:latin typeface="Times New Roman" panose="02020603050405020304" pitchFamily="18" charset="0"/>
+                <a:cs typeface="Times New Roman" panose="02020603050405020304" pitchFamily="18" charset="0"/>
+              </a:rPr>
+              <a:t>5</a:t>
+            </a:r>
+          </a:p>
+        </p:txBody>
+      </p:sp>
+      <p:sp>
+        <p:nvSpPr>
+          <p:cNvPr id="24" name="TextBox 23"/>
+          <p:cNvSpPr txBox="1"/>
+          <p:nvPr/>
+        </p:nvSpPr>
+        <p:spPr>
+          <a:xfrm>
+            <a:off x="8034417" y="370985"/>
+            <a:ext cx="1690565" cy="406265"/>
+          </a:xfrm>
+          <a:prstGeom prst="rect">
+            <a:avLst/>
+          </a:prstGeom>
+          <a:noFill/>
+        </p:spPr>
+        <p:txBody>
+          <a:bodyPr wrap="square" lIns="36576" tIns="18288" rIns="36576" bIns="18288" anchor="ctr">
+            <a:spAutoFit/>
+          </a:bodyPr>
+          <a:lstStyle/>
+          <a:p>
+            <a:pPr algn="l">
+              <a:spcBef>
+                <a:spcPts val="0"/>
+              </a:spcBef>
+              <a:spcAft>
+                <a:spcPts val="200"/>
+              </a:spcAft>
+            </a:pPr>
+            <a:r>
+              <a:rPr sz="1200" b="1" i="0" dirty="0">
+                <a:solidFill>
+                  <a:srgbClr val="FFFFFF"/>
+                </a:solidFill>
+                <a:latin typeface="Times New Roman" panose="02020603050405020304" pitchFamily="18" charset="0"/>
+                <a:cs typeface="Times New Roman" panose="02020603050405020304" pitchFamily="18" charset="0"/>
+              </a:rPr>
+              <a:t>EVALUATION AND COMMUNICATION</a:t>
+            </a:r>
+          </a:p>
+        </p:txBody>
+      </p:sp>
+      <p:sp>
+        <p:nvSpPr>
+          <p:cNvPr id="25" name="Rounded Rectangle 24"/>
+          <p:cNvSpPr/>
+          <p:nvPr/>
+        </p:nvSpPr>
+        <p:spPr>
+          <a:xfrm>
+            <a:off x="7970320" y="990575"/>
+            <a:ext cx="1706837" cy="3774375"/>
+          </a:xfrm>
+          <a:prstGeom prst="roundRect">
+            <a:avLst>
+              <a:gd name="adj" fmla="val 5000"/>
+            </a:avLst>
+          </a:prstGeom>
+          <a:solidFill>
+            <a:srgbClr val="FFFFFF"/>
+          </a:solidFill>
+          <a:ln w="19050">
+            <a:solidFill>
+              <a:srgbClr val="D86B00"/>
+            </a:solidFill>
+          </a:ln>
+        </p:spPr>
+        <p:style>
+          <a:lnRef idx="1">
+            <a:schemeClr val="accent1"/>
+          </a:lnRef>
+          <a:fillRef idx="3">
+            <a:schemeClr val="accent1"/>
+          </a:fillRef>
+          <a:effectRef idx="2">
+            <a:schemeClr val="accent1"/>
+          </a:effectRef>
+          <a:fontRef idx="minor">
+            <a:schemeClr val="lt1"/>
+          </a:fontRef>
+        </p:style>
+        <p:txBody>
+          <a:bodyPr rtlCol="0" anchor="ctr"/>
+          <a:lstStyle/>
+          <a:p>
+            <a:pPr algn="ctr"/>
+            <a:endParaRPr/>
+          </a:p>
+        </p:txBody>
+      </p:sp>
+      <p:sp>
+        <p:nvSpPr>
+          <p:cNvPr id="26" name="TextBox 25"/>
+          <p:cNvSpPr txBox="1"/>
+          <p:nvPr/>
+        </p:nvSpPr>
+        <p:spPr>
+          <a:xfrm>
+            <a:off x="8016039" y="1095211"/>
+            <a:ext cx="1554441" cy="3204595"/>
+          </a:xfrm>
+          <a:prstGeom prst="rect">
+            <a:avLst/>
+          </a:prstGeom>
+          <a:noFill/>
+        </p:spPr>
+        <p:txBody>
+          <a:bodyPr wrap="square" lIns="36576" tIns="18288" rIns="36576" bIns="18288" anchor="t">
+            <a:spAutoFit/>
+          </a:bodyPr>
+          <a:lstStyle/>
+          <a:p>
+            <a:pPr algn="l">
+              <a:lnSpc>
+                <a:spcPct val="150000"/>
+              </a:lnSpc>
+              <a:spcBef>
+                <a:spcPts val="0"/>
+              </a:spcBef>
+              <a:spcAft>
+                <a:spcPts val="600"/>
+              </a:spcAft>
+            </a:pPr>
+            <a:r>
+              <a:rPr sz="1200" b="1" i="0" dirty="0">
+                <a:latin typeface="Times New Roman" panose="02020603050405020304" pitchFamily="18" charset="0"/>
+                <a:cs typeface="Times New Roman" panose="02020603050405020304" pitchFamily="18" charset="0"/>
+              </a:rPr>
+              <a:t>•  </a:t>
+            </a:r>
+            <a:r>
+              <a:rPr sz="1200" b="0" i="0" dirty="0">
+                <a:latin typeface="Times New Roman" panose="02020603050405020304" pitchFamily="18" charset="0"/>
+                <a:cs typeface="Times New Roman" panose="02020603050405020304" pitchFamily="18" charset="0"/>
+              </a:rPr>
+              <a:t>Validate the framework's usability, accessibility and technical feasibility.</a:t>
+            </a:r>
+          </a:p>
+          <a:p>
+            <a:pPr algn="l">
+              <a:lnSpc>
+                <a:spcPct val="150000"/>
+              </a:lnSpc>
+              <a:spcBef>
+                <a:spcPts val="0"/>
+              </a:spcBef>
+              <a:spcAft>
+                <a:spcPts val="600"/>
+              </a:spcAft>
+            </a:pPr>
+            <a:r>
+              <a:rPr sz="1200" b="1" i="0" dirty="0">
+                <a:latin typeface="Times New Roman" panose="02020603050405020304" pitchFamily="18" charset="0"/>
+                <a:cs typeface="Times New Roman" panose="02020603050405020304" pitchFamily="18" charset="0"/>
+              </a:rPr>
+              <a:t>•  </a:t>
+            </a:r>
+            <a:r>
+              <a:rPr sz="1200" b="0" i="0" dirty="0">
+                <a:latin typeface="Times New Roman" panose="02020603050405020304" pitchFamily="18" charset="0"/>
+                <a:cs typeface="Times New Roman" panose="02020603050405020304" pitchFamily="18" charset="0"/>
+              </a:rPr>
+              <a:t>Discuss findings, limitations and future research directions.</a:t>
+            </a:r>
+          </a:p>
+          <a:p>
+            <a:pPr algn="l">
+              <a:lnSpc>
+                <a:spcPct val="150000"/>
+              </a:lnSpc>
+              <a:spcBef>
+                <a:spcPts val="0"/>
+              </a:spcBef>
+              <a:spcAft>
+                <a:spcPts val="600"/>
+              </a:spcAft>
+            </a:pPr>
+            <a:r>
+              <a:rPr sz="1200" b="1" i="0" dirty="0">
+                <a:latin typeface="Times New Roman" panose="02020603050405020304" pitchFamily="18" charset="0"/>
+                <a:cs typeface="Times New Roman" panose="02020603050405020304" pitchFamily="18" charset="0"/>
+              </a:rPr>
+              <a:t>•  </a:t>
+            </a:r>
+            <a:r>
+              <a:rPr sz="1200" b="0" i="0" dirty="0">
+                <a:latin typeface="Times New Roman" panose="02020603050405020304" pitchFamily="18" charset="0"/>
+                <a:cs typeface="Times New Roman" panose="02020603050405020304" pitchFamily="18" charset="0"/>
+              </a:rPr>
+              <a:t>Disseminate the framework, reference prototype and design guidelines.</a:t>
+            </a:r>
+          </a:p>
+        </p:txBody>
+      </p:sp>
+      <p:cxnSp>
+        <p:nvCxnSpPr>
+          <p:cNvPr id="27" name="Connector 26"/>
+          <p:cNvCxnSpPr/>
+          <p:nvPr/>
+        </p:nvCxnSpPr>
+        <p:spPr>
+          <a:xfrm>
+            <a:off x="1935431" y="2895527"/>
+            <a:ext cx="228594" cy="0"/>
+          </a:xfrm>
+          <a:prstGeom prst="line">
+            <a:avLst/>
+          </a:prstGeom>
+          <a:ln w="27940">
+            <a:solidFill>
+              <a:srgbClr val="2A2E33"/>
+            </a:solidFill>
+            <a:tailEnd type="triangle" w="med" len="med"/>
+          </a:ln>
+        </p:spPr>
+        <p:style>
+          <a:lnRef idx="2">
+            <a:schemeClr val="accent1"/>
+          </a:lnRef>
+          <a:fillRef idx="0">
+            <a:schemeClr val="accent1"/>
+          </a:fillRef>
+          <a:effectRef idx="1">
+            <a:schemeClr val="accent1"/>
+          </a:effectRef>
+          <a:fontRef idx="minor">
+            <a:schemeClr val="tx1"/>
+          </a:fontRef>
+        </p:style>
+      </p:cxnSp>
+      <p:cxnSp>
+        <p:nvCxnSpPr>
+          <p:cNvPr id="28" name="Connector 27"/>
+          <p:cNvCxnSpPr/>
+          <p:nvPr/>
+        </p:nvCxnSpPr>
+        <p:spPr>
+          <a:xfrm>
+            <a:off x="3870863" y="2895527"/>
+            <a:ext cx="228594" cy="0"/>
+          </a:xfrm>
+          <a:prstGeom prst="line">
+            <a:avLst/>
+          </a:prstGeom>
+          <a:ln w="27940">
+            <a:solidFill>
+              <a:srgbClr val="2A2E33"/>
+            </a:solidFill>
+            <a:tailEnd type="triangle" w="med" len="med"/>
+          </a:ln>
+        </p:spPr>
+        <p:style>
+          <a:lnRef idx="2">
+            <a:schemeClr val="accent1"/>
+          </a:lnRef>
+          <a:fillRef idx="0">
+            <a:schemeClr val="accent1"/>
+          </a:fillRef>
+          <a:effectRef idx="1">
+            <a:schemeClr val="accent1"/>
+          </a:effectRef>
+          <a:fontRef idx="minor">
+            <a:schemeClr val="tx1"/>
+          </a:fontRef>
+        </p:style>
+      </p:cxnSp>
+      <p:cxnSp>
+        <p:nvCxnSpPr>
+          <p:cNvPr id="29" name="Connector 28"/>
+          <p:cNvCxnSpPr/>
+          <p:nvPr/>
+        </p:nvCxnSpPr>
+        <p:spPr>
+          <a:xfrm>
+            <a:off x="5806294" y="2895527"/>
+            <a:ext cx="228595" cy="0"/>
+          </a:xfrm>
+          <a:prstGeom prst="line">
+            <a:avLst/>
+          </a:prstGeom>
+          <a:ln w="27940">
+            <a:solidFill>
+              <a:srgbClr val="2A2E33"/>
+            </a:solidFill>
+            <a:tailEnd type="triangle" w="med" len="med"/>
+          </a:ln>
+        </p:spPr>
+        <p:style>
+          <a:lnRef idx="2">
+            <a:schemeClr val="accent1"/>
+          </a:lnRef>
+          <a:fillRef idx="0">
+            <a:schemeClr val="accent1"/>
+          </a:fillRef>
+          <a:effectRef idx="1">
+            <a:schemeClr val="accent1"/>
+          </a:effectRef>
+          <a:fontRef idx="minor">
+            <a:schemeClr val="tx1"/>
+          </a:fontRef>
+        </p:style>
+      </p:cxnSp>
+      <p:cxnSp>
+        <p:nvCxnSpPr>
+          <p:cNvPr id="30" name="Connector 29"/>
+          <p:cNvCxnSpPr/>
+          <p:nvPr/>
+        </p:nvCxnSpPr>
+        <p:spPr>
+          <a:xfrm>
+            <a:off x="7741726" y="2895527"/>
+            <a:ext cx="228594" cy="0"/>
+          </a:xfrm>
+          <a:prstGeom prst="line">
+            <a:avLst/>
+          </a:prstGeom>
+          <a:ln w="27940">
+            <a:solidFill>
+              <a:srgbClr val="2A2E33"/>
+            </a:solidFill>
+            <a:tailEnd type="triangle" w="med" len="med"/>
+          </a:ln>
+        </p:spPr>
+        <p:style>
+          <a:lnRef idx="2">
+            <a:schemeClr val="accent1"/>
+          </a:lnRef>
+          <a:fillRef idx="0">
+            <a:schemeClr val="accent1"/>
+          </a:fillRef>
+          <a:effectRef idx="1">
+            <a:schemeClr val="accent1"/>
+          </a:effectRef>
+          <a:fontRef idx="minor">
+            <a:schemeClr val="tx1"/>
+          </a:fontRef>
+        </p:style>
+      </p:cxnSp>
+      <p:cxnSp>
+        <p:nvCxnSpPr>
+          <p:cNvPr id="31" name="Connector 30"/>
+          <p:cNvCxnSpPr/>
+          <p:nvPr/>
+        </p:nvCxnSpPr>
+        <p:spPr>
+          <a:xfrm>
+            <a:off x="9677158" y="2895527"/>
+            <a:ext cx="266693" cy="0"/>
+          </a:xfrm>
+          <a:prstGeom prst="line">
+            <a:avLst/>
+          </a:prstGeom>
+          <a:ln w="27940">
+            <a:solidFill>
+              <a:srgbClr val="2A2E33"/>
+            </a:solidFill>
+            <a:tailEnd type="triangle" w="med" len="med"/>
+          </a:ln>
+        </p:spPr>
+        <p:style>
+          <a:lnRef idx="2">
+            <a:schemeClr val="accent1"/>
+          </a:lnRef>
+          <a:fillRef idx="0">
+            <a:schemeClr val="accent1"/>
+          </a:fillRef>
+          <a:effectRef idx="1">
+            <a:schemeClr val="accent1"/>
+          </a:effectRef>
+          <a:fontRef idx="minor">
+            <a:schemeClr val="tx1"/>
+          </a:fontRef>
+        </p:style>
+      </p:cxnSp>
+      <p:sp>
+        <p:nvSpPr>
+          <p:cNvPr id="32" name="Rounded Rectangle 31"/>
+          <p:cNvSpPr/>
+          <p:nvPr/>
+        </p:nvSpPr>
+        <p:spPr>
+          <a:xfrm>
+            <a:off x="9943851" y="114297"/>
+            <a:ext cx="1981150" cy="4419489"/>
+          </a:xfrm>
+          <a:prstGeom prst="roundRect">
+            <a:avLst>
+              <a:gd name="adj" fmla="val 3000"/>
+            </a:avLst>
+          </a:prstGeom>
+          <a:solidFill>
+            <a:srgbClr val="F4F6F8"/>
+          </a:solidFill>
+          <a:ln w="20320">
+            <a:solidFill>
+              <a:srgbClr val="2E5A8C"/>
+            </a:solidFill>
+            <a:prstDash val="dash"/>
+          </a:ln>
+          <a:effectLst/>
+        </p:spPr>
+        <p:style>
+          <a:lnRef idx="1">
+            <a:schemeClr val="accent1"/>
+          </a:lnRef>
+          <a:fillRef idx="3">
+            <a:schemeClr val="accent1"/>
+          </a:fillRef>
+          <a:effectRef idx="2">
+            <a:schemeClr val="accent1"/>
+          </a:effectRef>
+          <a:fontRef idx="minor">
+            <a:schemeClr val="lt1"/>
+          </a:fontRef>
+        </p:style>
+        <p:txBody>
+          <a:bodyPr rtlCol="0" anchor="ctr"/>
+          <a:lstStyle/>
+          <a:p>
+            <a:pPr algn="ctr"/>
+            <a:endParaRPr>
+              <a:latin typeface="Times New Roman" panose="02020603050405020304" pitchFamily="18" charset="0"/>
+              <a:cs typeface="Times New Roman" panose="02020603050405020304" pitchFamily="18" charset="0"/>
+            </a:endParaRPr>
+          </a:p>
+        </p:txBody>
+      </p:sp>
+      <p:sp>
+        <p:nvSpPr>
+          <p:cNvPr id="33" name="TextBox 32"/>
+          <p:cNvSpPr txBox="1"/>
+          <p:nvPr/>
+        </p:nvSpPr>
+        <p:spPr>
+          <a:xfrm>
+            <a:off x="9943851" y="232091"/>
+            <a:ext cx="1981150" cy="221599"/>
+          </a:xfrm>
+          <a:prstGeom prst="rect">
+            <a:avLst/>
+          </a:prstGeom>
+          <a:noFill/>
+        </p:spPr>
+        <p:txBody>
+          <a:bodyPr wrap="square" lIns="36576" tIns="18288" rIns="36576" bIns="18288" anchor="ctr">
+            <a:spAutoFit/>
+          </a:bodyPr>
+          <a:lstStyle/>
+          <a:p>
+            <a:pPr algn="ctr">
+              <a:spcBef>
+                <a:spcPts val="0"/>
+              </a:spcBef>
+              <a:spcAft>
+                <a:spcPts val="200"/>
+              </a:spcAft>
+            </a:pPr>
+            <a:r>
+              <a:rPr sz="1200" b="1" i="0">
+                <a:solidFill>
+                  <a:srgbClr val="2E5A8C"/>
+                </a:solidFill>
+                <a:latin typeface="Times New Roman" panose="02020603050405020304" pitchFamily="18" charset="0"/>
+                <a:cs typeface="Times New Roman" panose="02020603050405020304" pitchFamily="18" charset="0"/>
+              </a:rPr>
+              <a:t>OUTPUTS</a:t>
+            </a:r>
+          </a:p>
+        </p:txBody>
+      </p:sp>
+      <p:sp>
+        <p:nvSpPr>
+          <p:cNvPr id="34" name="Rounded Rectangle 33"/>
+          <p:cNvSpPr/>
+          <p:nvPr/>
+        </p:nvSpPr>
+        <p:spPr>
+          <a:xfrm>
+            <a:off x="10081007" y="838179"/>
+            <a:ext cx="1706837" cy="800079"/>
+          </a:xfrm>
+          <a:prstGeom prst="roundRect">
+            <a:avLst>
+              <a:gd name="adj" fmla="val 6000"/>
+            </a:avLst>
+          </a:prstGeom>
+          <a:solidFill>
+            <a:srgbClr val="FFFFFF"/>
+          </a:solidFill>
+          <a:ln w="12700">
+            <a:solidFill>
+              <a:srgbClr val="D5DAE0"/>
+            </a:solidFill>
+          </a:ln>
+          <a:effectLst/>
+        </p:spPr>
+        <p:style>
+          <a:lnRef idx="1">
+            <a:schemeClr val="accent1"/>
+          </a:lnRef>
+          <a:fillRef idx="3">
+            <a:schemeClr val="accent1"/>
+          </a:fillRef>
+          <a:effectRef idx="2">
+            <a:schemeClr val="accent1"/>
+          </a:effectRef>
+          <a:fontRef idx="minor">
+            <a:schemeClr val="lt1"/>
+          </a:fontRef>
+        </p:style>
+        <p:txBody>
+          <a:bodyPr rtlCol="0" anchor="ctr"/>
+          <a:lstStyle/>
+          <a:p>
+            <a:pPr algn="ctr"/>
+            <a:endParaRPr>
+              <a:latin typeface="Times New Roman" panose="02020603050405020304" pitchFamily="18" charset="0"/>
+              <a:cs typeface="Times New Roman" panose="02020603050405020304" pitchFamily="18" charset="0"/>
+            </a:endParaRPr>
+          </a:p>
+        </p:txBody>
+      </p:sp>
+      <p:sp>
+        <p:nvSpPr>
+          <p:cNvPr id="35" name="Oval 34"/>
+          <p:cNvSpPr/>
+          <p:nvPr/>
+        </p:nvSpPr>
+        <p:spPr>
+          <a:xfrm>
+            <a:off x="10195305" y="1146781"/>
+            <a:ext cx="182875" cy="182875"/>
+          </a:xfrm>
+          <a:prstGeom prst="ellipse">
+            <a:avLst/>
+          </a:prstGeom>
+          <a:solidFill>
+            <a:srgbClr val="2E5A8C"/>
+          </a:solidFill>
+          <a:ln>
+            <a:noFill/>
+          </a:ln>
+          <a:effectLst/>
+        </p:spPr>
+        <p:style>
+          <a:lnRef idx="1">
+            <a:schemeClr val="accent1"/>
+          </a:lnRef>
+          <a:fillRef idx="3">
+            <a:schemeClr val="accent1"/>
+          </a:fillRef>
+          <a:effectRef idx="2">
+            <a:schemeClr val="accent1"/>
+          </a:effectRef>
+          <a:fontRef idx="minor">
+            <a:schemeClr val="lt1"/>
+          </a:fontRef>
+        </p:style>
+        <p:txBody>
+          <a:bodyPr wrap="square" lIns="36576" tIns="18288" rIns="36576" bIns="18288" rtlCol="0" anchor="ctr"/>
+          <a:lstStyle/>
+          <a:p>
+            <a:pPr algn="ctr">
+              <a:spcBef>
+                <a:spcPts val="0"/>
+              </a:spcBef>
+              <a:spcAft>
+                <a:spcPts val="0"/>
+              </a:spcAft>
+            </a:pPr>
+            <a:r>
+              <a:rPr sz="1100" b="1" i="0">
+                <a:solidFill>
+                  <a:srgbClr val="FFFFFF"/>
+                </a:solidFill>
+                <a:latin typeface="Times New Roman" panose="02020603050405020304" pitchFamily="18" charset="0"/>
+                <a:cs typeface="Times New Roman" panose="02020603050405020304" pitchFamily="18" charset="0"/>
+              </a:rPr>
+              <a:t>✓</a:t>
+            </a:r>
+          </a:p>
+        </p:txBody>
+      </p:sp>
+      <p:sp>
+        <p:nvSpPr>
+          <p:cNvPr id="36" name="TextBox 35"/>
+          <p:cNvSpPr txBox="1"/>
+          <p:nvPr/>
+        </p:nvSpPr>
+        <p:spPr>
+          <a:xfrm>
+            <a:off x="10416279" y="1035086"/>
+            <a:ext cx="1371565" cy="406265"/>
+          </a:xfrm>
+          <a:prstGeom prst="rect">
+            <a:avLst/>
+          </a:prstGeom>
+          <a:noFill/>
+        </p:spPr>
+        <p:txBody>
+          <a:bodyPr wrap="square" lIns="36576" tIns="18288" rIns="36576" bIns="18288" anchor="ctr">
+            <a:spAutoFit/>
+          </a:bodyPr>
+          <a:lstStyle/>
+          <a:p>
+            <a:pPr algn="l">
+              <a:spcBef>
+                <a:spcPts val="0"/>
+              </a:spcBef>
+              <a:spcAft>
+                <a:spcPts val="200"/>
+              </a:spcAft>
+            </a:pPr>
+            <a:r>
+              <a:rPr sz="1200" b="1" i="0" dirty="0">
+                <a:solidFill>
+                  <a:srgbClr val="20242A"/>
+                </a:solidFill>
+                <a:latin typeface="Times New Roman" panose="02020603050405020304" pitchFamily="18" charset="0"/>
+                <a:cs typeface="Times New Roman" panose="02020603050405020304" pitchFamily="18" charset="0"/>
+              </a:rPr>
+              <a:t>BCHAIN-ACCESS Framework</a:t>
+            </a:r>
+          </a:p>
+        </p:txBody>
+      </p:sp>
+      <p:sp>
+        <p:nvSpPr>
+          <p:cNvPr id="37" name="Rounded Rectangle 36"/>
+          <p:cNvSpPr/>
+          <p:nvPr/>
+        </p:nvSpPr>
+        <p:spPr>
+          <a:xfrm>
+            <a:off x="10081007" y="1727156"/>
+            <a:ext cx="1706837" cy="800079"/>
+          </a:xfrm>
+          <a:prstGeom prst="roundRect">
+            <a:avLst>
+              <a:gd name="adj" fmla="val 6000"/>
+            </a:avLst>
+          </a:prstGeom>
+          <a:solidFill>
+            <a:srgbClr val="FFFFFF"/>
+          </a:solidFill>
+          <a:ln w="12700">
+            <a:solidFill>
+              <a:srgbClr val="D5DAE0"/>
+            </a:solidFill>
+          </a:ln>
+          <a:effectLst/>
+        </p:spPr>
+        <p:style>
+          <a:lnRef idx="1">
+            <a:schemeClr val="accent1"/>
+          </a:lnRef>
+          <a:fillRef idx="3">
+            <a:schemeClr val="accent1"/>
+          </a:fillRef>
+          <a:effectRef idx="2">
+            <a:schemeClr val="accent1"/>
+          </a:effectRef>
+          <a:fontRef idx="minor">
+            <a:schemeClr val="lt1"/>
+          </a:fontRef>
+        </p:style>
+        <p:txBody>
+          <a:bodyPr rtlCol="0" anchor="ctr"/>
+          <a:lstStyle/>
+          <a:p>
+            <a:pPr algn="ctr"/>
+            <a:endParaRPr>
+              <a:latin typeface="Times New Roman" panose="02020603050405020304" pitchFamily="18" charset="0"/>
+              <a:cs typeface="Times New Roman" panose="02020603050405020304" pitchFamily="18" charset="0"/>
+            </a:endParaRPr>
+          </a:p>
+        </p:txBody>
+      </p:sp>
+      <p:sp>
+        <p:nvSpPr>
+          <p:cNvPr id="38" name="Oval 37"/>
+          <p:cNvSpPr/>
+          <p:nvPr/>
+        </p:nvSpPr>
+        <p:spPr>
+          <a:xfrm>
+            <a:off x="10195305" y="2035759"/>
+            <a:ext cx="182875" cy="182875"/>
+          </a:xfrm>
+          <a:prstGeom prst="ellipse">
+            <a:avLst/>
+          </a:prstGeom>
+          <a:solidFill>
+            <a:srgbClr val="2E5A8C"/>
+          </a:solidFill>
+          <a:ln>
+            <a:noFill/>
+          </a:ln>
+          <a:effectLst/>
+        </p:spPr>
+        <p:style>
+          <a:lnRef idx="1">
+            <a:schemeClr val="accent1"/>
+          </a:lnRef>
+          <a:fillRef idx="3">
+            <a:schemeClr val="accent1"/>
+          </a:fillRef>
+          <a:effectRef idx="2">
+            <a:schemeClr val="accent1"/>
+          </a:effectRef>
+          <a:fontRef idx="minor">
+            <a:schemeClr val="lt1"/>
+          </a:fontRef>
+        </p:style>
+        <p:txBody>
+          <a:bodyPr wrap="square" lIns="36576" tIns="18288" rIns="36576" bIns="18288" rtlCol="0" anchor="ctr"/>
+          <a:lstStyle/>
+          <a:p>
+            <a:pPr algn="ctr">
+              <a:spcBef>
+                <a:spcPts val="0"/>
+              </a:spcBef>
+              <a:spcAft>
+                <a:spcPts val="0"/>
+              </a:spcAft>
+            </a:pPr>
+            <a:r>
+              <a:rPr sz="1100" b="1" i="0">
+                <a:solidFill>
+                  <a:srgbClr val="FFFFFF"/>
+                </a:solidFill>
+                <a:latin typeface="Times New Roman" panose="02020603050405020304" pitchFamily="18" charset="0"/>
+                <a:cs typeface="Times New Roman" panose="02020603050405020304" pitchFamily="18" charset="0"/>
+              </a:rPr>
+              <a:t>✓</a:t>
+            </a:r>
+          </a:p>
+        </p:txBody>
+      </p:sp>
+      <p:sp>
+        <p:nvSpPr>
+          <p:cNvPr id="39" name="TextBox 38"/>
+          <p:cNvSpPr txBox="1"/>
+          <p:nvPr/>
+        </p:nvSpPr>
+        <p:spPr>
+          <a:xfrm>
+            <a:off x="10416279" y="1924063"/>
+            <a:ext cx="1371565" cy="406265"/>
+          </a:xfrm>
+          <a:prstGeom prst="rect">
+            <a:avLst/>
+          </a:prstGeom>
+          <a:noFill/>
+        </p:spPr>
+        <p:txBody>
+          <a:bodyPr wrap="square" lIns="36576" tIns="18288" rIns="36576" bIns="18288" anchor="ctr">
+            <a:spAutoFit/>
+          </a:bodyPr>
+          <a:lstStyle/>
+          <a:p>
+            <a:pPr algn="l">
+              <a:spcBef>
+                <a:spcPts val="0"/>
+              </a:spcBef>
+              <a:spcAft>
+                <a:spcPts val="200"/>
+              </a:spcAft>
+            </a:pPr>
+            <a:r>
+              <a:rPr sz="1200" b="1" i="0" dirty="0">
+                <a:solidFill>
+                  <a:srgbClr val="20242A"/>
+                </a:solidFill>
+                <a:latin typeface="Times New Roman" panose="02020603050405020304" pitchFamily="18" charset="0"/>
+                <a:cs typeface="Times New Roman" panose="02020603050405020304" pitchFamily="18" charset="0"/>
+              </a:rPr>
+              <a:t>Reference (Prototype)</a:t>
+            </a:r>
+          </a:p>
+        </p:txBody>
+      </p:sp>
+      <p:sp>
+        <p:nvSpPr>
+          <p:cNvPr id="40" name="Rounded Rectangle 39"/>
+          <p:cNvSpPr/>
+          <p:nvPr/>
+        </p:nvSpPr>
+        <p:spPr>
+          <a:xfrm>
+            <a:off x="10081007" y="2616134"/>
+            <a:ext cx="1706837" cy="800079"/>
+          </a:xfrm>
+          <a:prstGeom prst="roundRect">
+            <a:avLst>
+              <a:gd name="adj" fmla="val 6000"/>
+            </a:avLst>
+          </a:prstGeom>
+          <a:solidFill>
+            <a:srgbClr val="FFFFFF"/>
+          </a:solidFill>
+          <a:ln w="12700">
+            <a:solidFill>
+              <a:srgbClr val="D5DAE0"/>
+            </a:solidFill>
+          </a:ln>
+          <a:effectLst/>
+        </p:spPr>
+        <p:style>
+          <a:lnRef idx="1">
+            <a:schemeClr val="accent1"/>
+          </a:lnRef>
+          <a:fillRef idx="3">
+            <a:schemeClr val="accent1"/>
+          </a:fillRef>
+          <a:effectRef idx="2">
+            <a:schemeClr val="accent1"/>
+          </a:effectRef>
+          <a:fontRef idx="minor">
+            <a:schemeClr val="lt1"/>
+          </a:fontRef>
+        </p:style>
+        <p:txBody>
+          <a:bodyPr rtlCol="0" anchor="ctr"/>
+          <a:lstStyle/>
+          <a:p>
+            <a:pPr algn="ctr"/>
+            <a:endParaRPr>
+              <a:latin typeface="Times New Roman" panose="02020603050405020304" pitchFamily="18" charset="0"/>
+              <a:cs typeface="Times New Roman" panose="02020603050405020304" pitchFamily="18" charset="0"/>
+            </a:endParaRPr>
+          </a:p>
+        </p:txBody>
+      </p:sp>
+      <p:sp>
+        <p:nvSpPr>
+          <p:cNvPr id="41" name="Oval 40"/>
+          <p:cNvSpPr/>
+          <p:nvPr/>
+        </p:nvSpPr>
+        <p:spPr>
+          <a:xfrm>
+            <a:off x="10195305" y="2924736"/>
+            <a:ext cx="182875" cy="182875"/>
+          </a:xfrm>
+          <a:prstGeom prst="ellipse">
+            <a:avLst/>
+          </a:prstGeom>
+          <a:solidFill>
+            <a:srgbClr val="2E5A8C"/>
+          </a:solidFill>
+          <a:ln>
+            <a:noFill/>
+          </a:ln>
+          <a:effectLst/>
+        </p:spPr>
+        <p:style>
+          <a:lnRef idx="1">
+            <a:schemeClr val="accent1"/>
+          </a:lnRef>
+          <a:fillRef idx="3">
+            <a:schemeClr val="accent1"/>
+          </a:fillRef>
+          <a:effectRef idx="2">
+            <a:schemeClr val="accent1"/>
+          </a:effectRef>
+          <a:fontRef idx="minor">
+            <a:schemeClr val="lt1"/>
+          </a:fontRef>
+        </p:style>
+        <p:txBody>
+          <a:bodyPr wrap="square" lIns="36576" tIns="18288" rIns="36576" bIns="18288" rtlCol="0" anchor="ctr"/>
+          <a:lstStyle/>
+          <a:p>
+            <a:pPr algn="ctr">
+              <a:spcBef>
+                <a:spcPts val="0"/>
+              </a:spcBef>
+              <a:spcAft>
+                <a:spcPts val="0"/>
+              </a:spcAft>
+            </a:pPr>
+            <a:r>
+              <a:rPr sz="1100" b="1" i="0">
+                <a:solidFill>
+                  <a:srgbClr val="FFFFFF"/>
+                </a:solidFill>
+                <a:latin typeface="Times New Roman" panose="02020603050405020304" pitchFamily="18" charset="0"/>
+                <a:cs typeface="Times New Roman" panose="02020603050405020304" pitchFamily="18" charset="0"/>
+              </a:rPr>
+              <a:t>✓</a:t>
+            </a:r>
+          </a:p>
+        </p:txBody>
+      </p:sp>
+      <p:sp>
+        <p:nvSpPr>
+          <p:cNvPr id="42" name="TextBox 41"/>
+          <p:cNvSpPr txBox="1"/>
+          <p:nvPr/>
+        </p:nvSpPr>
+        <p:spPr>
+          <a:xfrm>
+            <a:off x="10416279" y="2905374"/>
+            <a:ext cx="1371565" cy="221599"/>
+          </a:xfrm>
+          <a:prstGeom prst="rect">
+            <a:avLst/>
+          </a:prstGeom>
+          <a:noFill/>
+        </p:spPr>
+        <p:txBody>
+          <a:bodyPr wrap="square" lIns="36576" tIns="18288" rIns="36576" bIns="18288" anchor="ctr">
+            <a:spAutoFit/>
+          </a:bodyPr>
+          <a:lstStyle/>
+          <a:p>
+            <a:pPr algn="l">
+              <a:spcBef>
+                <a:spcPts val="0"/>
+              </a:spcBef>
+              <a:spcAft>
+                <a:spcPts val="200"/>
+              </a:spcAft>
+            </a:pPr>
+            <a:r>
+              <a:rPr sz="1200" b="1" i="0" dirty="0">
+                <a:solidFill>
+                  <a:srgbClr val="20242A"/>
+                </a:solidFill>
+                <a:latin typeface="Times New Roman" panose="02020603050405020304" pitchFamily="18" charset="0"/>
+                <a:cs typeface="Times New Roman" panose="02020603050405020304" pitchFamily="18" charset="0"/>
+              </a:rPr>
+              <a:t>Expert Validation</a:t>
+            </a:r>
+          </a:p>
+        </p:txBody>
+      </p:sp>
+      <p:sp>
+        <p:nvSpPr>
+          <p:cNvPr id="43" name="Rounded Rectangle 42"/>
+          <p:cNvSpPr/>
+          <p:nvPr/>
+        </p:nvSpPr>
+        <p:spPr>
+          <a:xfrm>
+            <a:off x="10081007" y="3505112"/>
+            <a:ext cx="1706837" cy="800079"/>
+          </a:xfrm>
+          <a:prstGeom prst="roundRect">
+            <a:avLst>
+              <a:gd name="adj" fmla="val 6000"/>
+            </a:avLst>
+          </a:prstGeom>
+          <a:solidFill>
+            <a:srgbClr val="FFFFFF"/>
+          </a:solidFill>
+          <a:ln w="12700">
+            <a:solidFill>
+              <a:srgbClr val="D5DAE0"/>
+            </a:solidFill>
+          </a:ln>
+          <a:effectLst/>
+        </p:spPr>
+        <p:style>
+          <a:lnRef idx="1">
+            <a:schemeClr val="accent1"/>
+          </a:lnRef>
+          <a:fillRef idx="3">
+            <a:schemeClr val="accent1"/>
+          </a:fillRef>
+          <a:effectRef idx="2">
+            <a:schemeClr val="accent1"/>
+          </a:effectRef>
+          <a:fontRef idx="minor">
+            <a:schemeClr val="lt1"/>
+          </a:fontRef>
+        </p:style>
+        <p:txBody>
+          <a:bodyPr rtlCol="0" anchor="ctr"/>
+          <a:lstStyle/>
+          <a:p>
+            <a:pPr algn="ctr"/>
+            <a:endParaRPr>
+              <a:latin typeface="Times New Roman" panose="02020603050405020304" pitchFamily="18" charset="0"/>
+              <a:cs typeface="Times New Roman" panose="02020603050405020304" pitchFamily="18" charset="0"/>
+            </a:endParaRPr>
+          </a:p>
+        </p:txBody>
+      </p:sp>
+      <p:sp>
+        <p:nvSpPr>
+          <p:cNvPr id="44" name="Oval 43"/>
+          <p:cNvSpPr/>
+          <p:nvPr/>
+        </p:nvSpPr>
+        <p:spPr>
+          <a:xfrm>
+            <a:off x="10195305" y="3813714"/>
+            <a:ext cx="182875" cy="182875"/>
+          </a:xfrm>
+          <a:prstGeom prst="ellipse">
+            <a:avLst/>
+          </a:prstGeom>
+          <a:solidFill>
+            <a:srgbClr val="2E5A8C"/>
+          </a:solidFill>
+          <a:ln>
+            <a:noFill/>
+          </a:ln>
+          <a:effectLst/>
+        </p:spPr>
+        <p:style>
+          <a:lnRef idx="1">
+            <a:schemeClr val="accent1"/>
+          </a:lnRef>
+          <a:fillRef idx="3">
+            <a:schemeClr val="accent1"/>
+          </a:fillRef>
+          <a:effectRef idx="2">
+            <a:schemeClr val="accent1"/>
+          </a:effectRef>
+          <a:fontRef idx="minor">
+            <a:schemeClr val="lt1"/>
+          </a:fontRef>
+        </p:style>
+        <p:txBody>
+          <a:bodyPr wrap="square" lIns="36576" tIns="18288" rIns="36576" bIns="18288" rtlCol="0" anchor="ctr"/>
+          <a:lstStyle/>
+          <a:p>
+            <a:pPr algn="ctr">
+              <a:spcBef>
+                <a:spcPts val="0"/>
+              </a:spcBef>
+              <a:spcAft>
+                <a:spcPts val="0"/>
+              </a:spcAft>
+            </a:pPr>
+            <a:r>
+              <a:rPr sz="1100" b="1" i="0">
+                <a:solidFill>
+                  <a:srgbClr val="FFFFFF"/>
+                </a:solidFill>
+                <a:latin typeface="Times New Roman" panose="02020603050405020304" pitchFamily="18" charset="0"/>
+                <a:cs typeface="Times New Roman" panose="02020603050405020304" pitchFamily="18" charset="0"/>
+              </a:rPr>
+              <a:t>✓</a:t>
+            </a:r>
+          </a:p>
+        </p:txBody>
+      </p:sp>
+      <p:sp>
+        <p:nvSpPr>
+          <p:cNvPr id="45" name="TextBox 44"/>
+          <p:cNvSpPr txBox="1"/>
+          <p:nvPr/>
+        </p:nvSpPr>
+        <p:spPr>
+          <a:xfrm>
+            <a:off x="10416279" y="3702019"/>
+            <a:ext cx="1371565" cy="406265"/>
+          </a:xfrm>
+          <a:prstGeom prst="rect">
+            <a:avLst/>
+          </a:prstGeom>
+          <a:noFill/>
+        </p:spPr>
+        <p:txBody>
+          <a:bodyPr wrap="square" lIns="36576" tIns="18288" rIns="36576" bIns="18288" anchor="ctr">
+            <a:spAutoFit/>
+          </a:bodyPr>
+          <a:lstStyle/>
+          <a:p>
+            <a:pPr algn="l">
+              <a:spcBef>
+                <a:spcPts val="0"/>
+              </a:spcBef>
+              <a:spcAft>
+                <a:spcPts val="200"/>
+              </a:spcAft>
+            </a:pPr>
+            <a:r>
+              <a:rPr sz="1200" b="1" i="0" dirty="0">
+                <a:solidFill>
+                  <a:srgbClr val="20242A"/>
+                </a:solidFill>
+                <a:latin typeface="Times New Roman" panose="02020603050405020304" pitchFamily="18" charset="0"/>
+                <a:cs typeface="Times New Roman" panose="02020603050405020304" pitchFamily="18" charset="0"/>
+              </a:rPr>
+              <a:t>Accessibility Design Guidelines</a:t>
+            </a:r>
+          </a:p>
+        </p:txBody>
+      </p:sp>
+      <p:sp>
+        <p:nvSpPr>
+          <p:cNvPr id="46" name="Rounded Rectangle 45"/>
+          <p:cNvSpPr/>
+          <p:nvPr/>
+        </p:nvSpPr>
+        <p:spPr>
+          <a:xfrm>
+            <a:off x="3467013" y="5395623"/>
+            <a:ext cx="4495687" cy="723881"/>
+          </a:xfrm>
+          <a:prstGeom prst="roundRect">
+            <a:avLst>
+              <a:gd name="adj" fmla="val 6000"/>
+            </a:avLst>
+          </a:prstGeom>
+          <a:solidFill>
+            <a:srgbClr val="FFFFFF"/>
+          </a:solidFill>
+          <a:ln w="19050">
+            <a:solidFill>
+              <a:srgbClr val="004B9E"/>
+            </a:solidFill>
+          </a:ln>
+        </p:spPr>
+        <p:style>
+          <a:lnRef idx="1">
+            <a:schemeClr val="accent1"/>
+          </a:lnRef>
+          <a:fillRef idx="3">
+            <a:schemeClr val="accent1"/>
+          </a:fillRef>
+          <a:effectRef idx="2">
+            <a:schemeClr val="accent1"/>
+          </a:effectRef>
+          <a:fontRef idx="minor">
+            <a:schemeClr val="lt1"/>
+          </a:fontRef>
+        </p:style>
+        <p:txBody>
+          <a:bodyPr rtlCol="0" anchor="ctr"/>
+          <a:lstStyle/>
+          <a:p>
+            <a:pPr algn="ctr"/>
+            <a:endParaRPr/>
+          </a:p>
+        </p:txBody>
+      </p:sp>
+      <p:sp>
+        <p:nvSpPr>
+          <p:cNvPr id="47" name="TextBox 46"/>
+          <p:cNvSpPr txBox="1"/>
+          <p:nvPr/>
+        </p:nvSpPr>
+        <p:spPr>
+          <a:xfrm>
+            <a:off x="3467013" y="5510831"/>
+            <a:ext cx="4495687" cy="493468"/>
+          </a:xfrm>
+          <a:prstGeom prst="rect">
+            <a:avLst/>
+          </a:prstGeom>
+          <a:noFill/>
+        </p:spPr>
+        <p:txBody>
+          <a:bodyPr wrap="square" lIns="36576" tIns="18288" rIns="36576" bIns="18288" anchor="ctr">
+            <a:spAutoFit/>
+          </a:bodyPr>
+          <a:lstStyle/>
+          <a:p>
+            <a:pPr algn="ctr">
+              <a:spcBef>
+                <a:spcPts val="0"/>
+              </a:spcBef>
+              <a:spcAft>
+                <a:spcPts val="200"/>
+              </a:spcAft>
+            </a:pPr>
+            <a:r>
+              <a:rPr sz="1600" b="1" dirty="0">
+                <a:solidFill>
+                  <a:srgbClr val="004B9E"/>
+                </a:solidFill>
+                <a:latin typeface="Times New Roman" panose="02020603050405020304" pitchFamily="18" charset="0"/>
+                <a:cs typeface="Times New Roman" panose="02020603050405020304" pitchFamily="18" charset="0"/>
+              </a:rPr>
+              <a:t>Iterative Feedback Loop</a:t>
+            </a:r>
+          </a:p>
+          <a:p>
+            <a:pPr algn="ctr">
+              <a:spcBef>
+                <a:spcPts val="0"/>
+              </a:spcBef>
+              <a:spcAft>
+                <a:spcPts val="200"/>
+              </a:spcAft>
+            </a:pPr>
+            <a:r>
+              <a:rPr sz="1200" b="1" i="0" dirty="0">
+                <a:latin typeface="Times New Roman" panose="02020603050405020304" pitchFamily="18" charset="0"/>
+                <a:cs typeface="Times New Roman" panose="02020603050405020304" pitchFamily="18" charset="0"/>
+              </a:rPr>
+              <a:t>(Refinement based on evaluation results and expert feedback)</a:t>
+            </a:r>
+          </a:p>
+        </p:txBody>
+      </p:sp>
+      <p:cxnSp>
+        <p:nvCxnSpPr>
+          <p:cNvPr id="48" name="Connector 47"/>
+          <p:cNvCxnSpPr/>
+          <p:nvPr/>
+        </p:nvCxnSpPr>
+        <p:spPr>
+          <a:xfrm>
+            <a:off x="1082012" y="5113690"/>
+            <a:ext cx="7741727" cy="0"/>
+          </a:xfrm>
+          <a:prstGeom prst="line">
+            <a:avLst/>
+          </a:prstGeom>
+          <a:ln w="38100">
+            <a:solidFill>
+              <a:schemeClr val="tx1"/>
+            </a:solidFill>
+            <a:prstDash val="sysDot"/>
+          </a:ln>
+        </p:spPr>
+        <p:style>
+          <a:lnRef idx="2">
+            <a:schemeClr val="accent1"/>
+          </a:lnRef>
+          <a:fillRef idx="0">
+            <a:schemeClr val="accent1"/>
+          </a:fillRef>
+          <a:effectRef idx="1">
+            <a:schemeClr val="accent1"/>
+          </a:effectRef>
+          <a:fontRef idx="minor">
+            <a:schemeClr val="tx1"/>
+          </a:fontRef>
+        </p:style>
+      </p:cxnSp>
+      <p:cxnSp>
+        <p:nvCxnSpPr>
+          <p:cNvPr id="49" name="Connector 48"/>
+          <p:cNvCxnSpPr/>
+          <p:nvPr/>
+        </p:nvCxnSpPr>
+        <p:spPr>
+          <a:xfrm flipV="1">
+            <a:off x="5714857" y="5113690"/>
+            <a:ext cx="0" cy="281933"/>
+          </a:xfrm>
+          <a:prstGeom prst="line">
+            <a:avLst/>
+          </a:prstGeom>
+          <a:ln w="28575">
+            <a:solidFill>
+              <a:schemeClr val="tx1"/>
+            </a:solidFill>
+            <a:prstDash val="sysDot"/>
+          </a:ln>
+        </p:spPr>
+        <p:style>
+          <a:lnRef idx="2">
+            <a:schemeClr val="accent1"/>
+          </a:lnRef>
+          <a:fillRef idx="0">
+            <a:schemeClr val="accent1"/>
+          </a:fillRef>
+          <a:effectRef idx="1">
+            <a:schemeClr val="accent1"/>
+          </a:effectRef>
+          <a:fontRef idx="minor">
+            <a:schemeClr val="tx1"/>
+          </a:fontRef>
+        </p:style>
+      </p:cxnSp>
+      <p:cxnSp>
+        <p:nvCxnSpPr>
+          <p:cNvPr id="50" name="Connector 49"/>
+          <p:cNvCxnSpPr/>
+          <p:nvPr/>
+        </p:nvCxnSpPr>
+        <p:spPr>
+          <a:xfrm flipV="1">
+            <a:off x="1082012" y="4786038"/>
+            <a:ext cx="0" cy="327652"/>
+          </a:xfrm>
+          <a:prstGeom prst="line">
+            <a:avLst/>
+          </a:prstGeom>
+          <a:ln w="28575">
+            <a:solidFill>
+              <a:schemeClr val="tx1"/>
+            </a:solidFill>
+            <a:prstDash val="sysDot"/>
+            <a:tailEnd type="triangle" w="med" len="med"/>
+          </a:ln>
+        </p:spPr>
+        <p:style>
+          <a:lnRef idx="2">
+            <a:schemeClr val="accent1"/>
+          </a:lnRef>
+          <a:fillRef idx="0">
+            <a:schemeClr val="accent1"/>
+          </a:fillRef>
+          <a:effectRef idx="1">
+            <a:schemeClr val="accent1"/>
+          </a:effectRef>
+          <a:fontRef idx="minor">
+            <a:schemeClr val="tx1"/>
+          </a:fontRef>
+        </p:style>
+      </p:cxnSp>
+      <p:cxnSp>
+        <p:nvCxnSpPr>
+          <p:cNvPr id="51" name="Connector 50"/>
+          <p:cNvCxnSpPr/>
+          <p:nvPr/>
+        </p:nvCxnSpPr>
+        <p:spPr>
+          <a:xfrm flipV="1">
+            <a:off x="3017444" y="4786038"/>
+            <a:ext cx="0" cy="327652"/>
+          </a:xfrm>
+          <a:prstGeom prst="line">
+            <a:avLst/>
+          </a:prstGeom>
+          <a:ln w="28575">
+            <a:solidFill>
+              <a:schemeClr val="tx1"/>
+            </a:solidFill>
+            <a:prstDash val="sysDot"/>
+            <a:tailEnd type="triangle" w="med" len="med"/>
+          </a:ln>
+        </p:spPr>
+        <p:style>
+          <a:lnRef idx="2">
+            <a:schemeClr val="accent1"/>
+          </a:lnRef>
+          <a:fillRef idx="0">
+            <a:schemeClr val="accent1"/>
+          </a:fillRef>
+          <a:effectRef idx="1">
+            <a:schemeClr val="accent1"/>
+          </a:effectRef>
+          <a:fontRef idx="minor">
+            <a:schemeClr val="tx1"/>
+          </a:fontRef>
+        </p:style>
+      </p:cxnSp>
+      <p:cxnSp>
+        <p:nvCxnSpPr>
+          <p:cNvPr id="52" name="Connector 51"/>
+          <p:cNvCxnSpPr/>
+          <p:nvPr/>
+        </p:nvCxnSpPr>
+        <p:spPr>
+          <a:xfrm flipV="1">
+            <a:off x="4952876" y="4786038"/>
+            <a:ext cx="0" cy="327652"/>
+          </a:xfrm>
+          <a:prstGeom prst="line">
+            <a:avLst/>
+          </a:prstGeom>
+          <a:ln w="28575">
+            <a:solidFill>
+              <a:schemeClr val="tx1"/>
+            </a:solidFill>
+            <a:prstDash val="sysDot"/>
+            <a:tailEnd type="triangle" w="med" len="med"/>
+          </a:ln>
+        </p:spPr>
+        <p:style>
+          <a:lnRef idx="2">
+            <a:schemeClr val="accent1"/>
+          </a:lnRef>
+          <a:fillRef idx="0">
+            <a:schemeClr val="accent1"/>
+          </a:fillRef>
+          <a:effectRef idx="1">
+            <a:schemeClr val="accent1"/>
+          </a:effectRef>
+          <a:fontRef idx="minor">
+            <a:schemeClr val="tx1"/>
+          </a:fontRef>
+        </p:style>
+      </p:cxnSp>
+      <p:cxnSp>
+        <p:nvCxnSpPr>
+          <p:cNvPr id="53" name="Connector 52"/>
+          <p:cNvCxnSpPr/>
+          <p:nvPr/>
+        </p:nvCxnSpPr>
+        <p:spPr>
+          <a:xfrm flipV="1">
+            <a:off x="6888307" y="4786038"/>
+            <a:ext cx="0" cy="327652"/>
+          </a:xfrm>
+          <a:prstGeom prst="line">
+            <a:avLst/>
+          </a:prstGeom>
+          <a:ln w="28575">
+            <a:solidFill>
+              <a:schemeClr val="tx1"/>
+            </a:solidFill>
+            <a:prstDash val="sysDot"/>
+            <a:tailEnd type="triangle" w="med" len="med"/>
+          </a:ln>
+        </p:spPr>
+        <p:style>
+          <a:lnRef idx="2">
+            <a:schemeClr val="accent1"/>
+          </a:lnRef>
+          <a:fillRef idx="0">
+            <a:schemeClr val="accent1"/>
+          </a:fillRef>
+          <a:effectRef idx="1">
+            <a:schemeClr val="accent1"/>
+          </a:effectRef>
+          <a:fontRef idx="minor">
+            <a:schemeClr val="tx1"/>
+          </a:fontRef>
+        </p:style>
+      </p:cxnSp>
+      <p:cxnSp>
+        <p:nvCxnSpPr>
+          <p:cNvPr id="54" name="Connector 53"/>
+          <p:cNvCxnSpPr/>
+          <p:nvPr/>
+        </p:nvCxnSpPr>
+        <p:spPr>
+          <a:xfrm flipV="1">
+            <a:off x="8823739" y="4786038"/>
+            <a:ext cx="0" cy="327652"/>
+          </a:xfrm>
+          <a:prstGeom prst="line">
+            <a:avLst/>
+          </a:prstGeom>
+          <a:ln w="28575">
+            <a:solidFill>
+              <a:schemeClr val="tx1"/>
+            </a:solidFill>
+            <a:prstDash val="sysDot"/>
+            <a:tailEnd type="triangle" w="med" len="med"/>
+          </a:ln>
+        </p:spPr>
+        <p:style>
+          <a:lnRef idx="2">
+            <a:schemeClr val="accent1"/>
+          </a:lnRef>
+          <a:fillRef idx="0">
+            <a:schemeClr val="accent1"/>
+          </a:fillRef>
+          <a:effectRef idx="1">
+            <a:schemeClr val="accent1"/>
+          </a:effectRef>
+          <a:fontRef idx="minor">
+            <a:schemeClr val="tx1"/>
+          </a:fontRef>
+        </p:style>
+      </p:cxnSp>
+      <p:sp>
+        <p:nvSpPr>
+          <p:cNvPr id="55" name="Rounded Rectangle 54"/>
+          <p:cNvSpPr/>
+          <p:nvPr/>
+        </p:nvSpPr>
+        <p:spPr>
+          <a:xfrm>
+            <a:off x="228594" y="6271101"/>
+            <a:ext cx="11696407" cy="1082014"/>
+          </a:xfrm>
+          <a:prstGeom prst="roundRect">
+            <a:avLst>
+              <a:gd name="adj" fmla="val 3000"/>
+            </a:avLst>
+          </a:prstGeom>
+          <a:solidFill>
+            <a:srgbClr val="FFFFFF"/>
+          </a:solidFill>
+          <a:ln w="19050">
+            <a:solidFill>
+              <a:srgbClr val="00428D"/>
+            </a:solidFill>
+          </a:ln>
+        </p:spPr>
+        <p:style>
+          <a:lnRef idx="1">
+            <a:schemeClr val="accent1"/>
+          </a:lnRef>
+          <a:fillRef idx="3">
+            <a:schemeClr val="accent1"/>
+          </a:fillRef>
+          <a:effectRef idx="2">
+            <a:schemeClr val="accent1"/>
+          </a:effectRef>
+          <a:fontRef idx="minor">
+            <a:schemeClr val="lt1"/>
+          </a:fontRef>
+        </p:style>
+        <p:txBody>
+          <a:bodyPr rtlCol="0" anchor="ctr"/>
+          <a:lstStyle/>
+          <a:p>
+            <a:pPr algn="ctr"/>
+            <a:endParaRPr/>
+          </a:p>
+        </p:txBody>
+      </p:sp>
+      <p:sp>
+        <p:nvSpPr>
+          <p:cNvPr id="56" name="TextBox 55"/>
+          <p:cNvSpPr txBox="1"/>
+          <p:nvPr/>
+        </p:nvSpPr>
+        <p:spPr>
+          <a:xfrm>
+            <a:off x="228594" y="6286580"/>
+            <a:ext cx="11696407" cy="369332"/>
+          </a:xfrm>
+          <a:prstGeom prst="rect">
+            <a:avLst/>
+          </a:prstGeom>
+          <a:solidFill>
+            <a:srgbClr val="00428D"/>
+          </a:solidFill>
+          <a:ln>
+            <a:noFill/>
+          </a:ln>
+        </p:spPr>
+        <p:style>
+          <a:lnRef idx="1">
+            <a:schemeClr val="accent1"/>
+          </a:lnRef>
+          <a:fillRef idx="3">
+            <a:schemeClr val="accent1"/>
+          </a:fillRef>
+          <a:effectRef idx="2">
+            <a:schemeClr val="accent1"/>
+          </a:effectRef>
+          <a:fontRef idx="minor">
+            <a:schemeClr val="lt1"/>
+          </a:fontRef>
+        </p:style>
+        <p:txBody>
+          <a:bodyPr rtlCol="0" anchor="ctr"/>
+          <a:lstStyle>
+            <a:defPPr>
+              <a:defRPr lang="en-US"/>
+            </a:defPPr>
+            <a:lvl1pPr algn="ctr">
+              <a:defRPr>
+                <a:solidFill>
+                  <a:schemeClr val="lt1"/>
+                </a:solidFill>
+              </a:defRPr>
+            </a:lvl1pPr>
+            <a:lvl2pPr>
+              <a:defRPr>
+                <a:solidFill>
+                  <a:schemeClr val="lt1"/>
+                </a:solidFill>
+              </a:defRPr>
+            </a:lvl2pPr>
+            <a:lvl3pPr>
+              <a:defRPr>
+                <a:solidFill>
+                  <a:schemeClr val="lt1"/>
+                </a:solidFill>
+              </a:defRPr>
+            </a:lvl3pPr>
+            <a:lvl4pPr>
+              <a:defRPr>
+                <a:solidFill>
+                  <a:schemeClr val="lt1"/>
+                </a:solidFill>
+              </a:defRPr>
+            </a:lvl4pPr>
+            <a:lvl5pPr>
+              <a:defRPr>
+                <a:solidFill>
+                  <a:schemeClr val="lt1"/>
+                </a:solidFill>
+              </a:defRPr>
+            </a:lvl5pPr>
+            <a:lvl6pPr>
+              <a:defRPr>
+                <a:solidFill>
+                  <a:schemeClr val="lt1"/>
+                </a:solidFill>
+              </a:defRPr>
+            </a:lvl6pPr>
+            <a:lvl7pPr>
+              <a:defRPr>
+                <a:solidFill>
+                  <a:schemeClr val="lt1"/>
+                </a:solidFill>
+              </a:defRPr>
+            </a:lvl7pPr>
+            <a:lvl8pPr>
+              <a:defRPr>
+                <a:solidFill>
+                  <a:schemeClr val="lt1"/>
+                </a:solidFill>
+              </a:defRPr>
+            </a:lvl8pPr>
+            <a:lvl9pPr>
+              <a:defRPr>
+                <a:solidFill>
+                  <a:schemeClr val="lt1"/>
+                </a:solidFill>
+              </a:defRPr>
+            </a:lvl9pPr>
+          </a:lstStyle>
+          <a:p>
+            <a:r>
+              <a:rPr dirty="0">
+                <a:latin typeface="Times New Roman" panose="02020603050405020304" pitchFamily="18" charset="0"/>
+                <a:cs typeface="Times New Roman" panose="02020603050405020304" pitchFamily="18" charset="0"/>
+              </a:rPr>
+              <a:t>KNOWLEDGE BASE</a:t>
+            </a:r>
+          </a:p>
+        </p:txBody>
+      </p:sp>
       <p:pic>
         <p:nvPicPr>
-          <p:cNvPr id="2" name="Picture 1" descr="dsrm_m.emf"/>
+          <p:cNvPr id="57" name="Picture 56" descr="kb_book.png"/>
           <p:cNvPicPr>
             <a:picLocks noChangeAspect="1"/>
           </p:cNvPicPr>
@@ -3104,14 +6136,627 @@
         </p:blipFill>
         <p:spPr>
           <a:xfrm>
-            <a:off x="0" y="0"/>
-            <a:ext cx="12191695" cy="7619809"/>
+            <a:off x="1238219" y="6621616"/>
+            <a:ext cx="320031" cy="320031"/>
           </a:xfrm>
           <a:prstGeom prst="rect">
             <a:avLst/>
           </a:prstGeom>
         </p:spPr>
       </p:pic>
+      <p:sp>
+        <p:nvSpPr>
+          <p:cNvPr id="58" name="TextBox 57"/>
+          <p:cNvSpPr txBox="1"/>
+          <p:nvPr/>
+        </p:nvSpPr>
+        <p:spPr>
+          <a:xfrm>
+            <a:off x="304792" y="6833464"/>
+            <a:ext cx="2186885" cy="467820"/>
+          </a:xfrm>
+          <a:prstGeom prst="rect">
+            <a:avLst/>
+          </a:prstGeom>
+          <a:noFill/>
+        </p:spPr>
+        <p:txBody>
+          <a:bodyPr wrap="square" lIns="36576" tIns="18288" rIns="36576" bIns="18288" anchor="ctr">
+            <a:spAutoFit/>
+          </a:bodyPr>
+          <a:lstStyle/>
+          <a:p>
+            <a:pPr algn="ctr">
+              <a:spcAft>
+                <a:spcPts val="200"/>
+              </a:spcAft>
+            </a:pPr>
+            <a:r>
+              <a:rPr sz="1400" b="1" dirty="0">
+                <a:solidFill>
+                  <a:srgbClr val="004B9E"/>
+                </a:solidFill>
+                <a:latin typeface="Times New Roman" panose="02020603050405020304" pitchFamily="18" charset="0"/>
+                <a:cs typeface="Times New Roman" panose="02020603050405020304" pitchFamily="18" charset="0"/>
+              </a:rPr>
+              <a:t>Blockchain Healthcare Literature</a:t>
+            </a:r>
+          </a:p>
+        </p:txBody>
+      </p:sp>
+      <p:pic>
+        <p:nvPicPr>
+          <p:cNvPr id="59" name="Picture 58" descr="kb_ui.png"/>
+          <p:cNvPicPr>
+            <a:picLocks noChangeAspect="1"/>
+          </p:cNvPicPr>
+          <p:nvPr/>
+        </p:nvPicPr>
+        <p:blipFill>
+          <a:blip r:embed="rId3"/>
+          <a:stretch>
+            <a:fillRect/>
+          </a:stretch>
+        </p:blipFill>
+        <p:spPr>
+          <a:xfrm>
+            <a:off x="3298100" y="6634316"/>
+            <a:ext cx="320031" cy="320031"/>
+          </a:xfrm>
+          <a:prstGeom prst="rect">
+            <a:avLst/>
+          </a:prstGeom>
+        </p:spPr>
+      </p:pic>
+      <p:sp>
+        <p:nvSpPr>
+          <p:cNvPr id="60" name="TextBox 59"/>
+          <p:cNvSpPr txBox="1"/>
+          <p:nvPr/>
+        </p:nvSpPr>
+        <p:spPr>
+          <a:xfrm>
+            <a:off x="2390073" y="6833463"/>
+            <a:ext cx="2186885" cy="467820"/>
+          </a:xfrm>
+          <a:prstGeom prst="rect">
+            <a:avLst/>
+          </a:prstGeom>
+          <a:noFill/>
+        </p:spPr>
+        <p:txBody>
+          <a:bodyPr wrap="square" lIns="36576" tIns="18288" rIns="36576" bIns="18288" anchor="ctr">
+            <a:spAutoFit/>
+          </a:bodyPr>
+          <a:lstStyle/>
+          <a:p>
+            <a:pPr algn="ctr">
+              <a:spcBef>
+                <a:spcPts val="0"/>
+              </a:spcBef>
+              <a:spcAft>
+                <a:spcPts val="200"/>
+              </a:spcAft>
+            </a:pPr>
+            <a:r>
+              <a:rPr sz="1400" b="1" dirty="0">
+                <a:solidFill>
+                  <a:srgbClr val="004B9E"/>
+                </a:solidFill>
+                <a:latin typeface="Times New Roman" panose="02020603050405020304" pitchFamily="18" charset="0"/>
+                <a:cs typeface="Times New Roman" panose="02020603050405020304" pitchFamily="18" charset="0"/>
+              </a:rPr>
+              <a:t>HCI, UI/UX and Accessibility Literature</a:t>
+            </a:r>
+          </a:p>
+        </p:txBody>
+      </p:sp>
+      <p:pic>
+        <p:nvPicPr>
+          <p:cNvPr id="61" name="Picture 60" descr="kb_access.png"/>
+          <p:cNvPicPr>
+            <a:picLocks noChangeAspect="1"/>
+          </p:cNvPicPr>
+          <p:nvPr/>
+        </p:nvPicPr>
+        <p:blipFill>
+          <a:blip r:embed="rId4"/>
+          <a:stretch>
+            <a:fillRect/>
+          </a:stretch>
+        </p:blipFill>
+        <p:spPr>
+          <a:xfrm>
+            <a:off x="5497682" y="6659716"/>
+            <a:ext cx="320031" cy="320031"/>
+          </a:xfrm>
+          <a:prstGeom prst="rect">
+            <a:avLst/>
+          </a:prstGeom>
+        </p:spPr>
+      </p:pic>
+      <p:sp>
+        <p:nvSpPr>
+          <p:cNvPr id="62" name="TextBox 61"/>
+          <p:cNvSpPr txBox="1"/>
+          <p:nvPr/>
+        </p:nvSpPr>
+        <p:spPr>
+          <a:xfrm>
+            <a:off x="4640455" y="6833463"/>
+            <a:ext cx="2186885" cy="467820"/>
+          </a:xfrm>
+          <a:prstGeom prst="rect">
+            <a:avLst/>
+          </a:prstGeom>
+          <a:noFill/>
+        </p:spPr>
+        <p:txBody>
+          <a:bodyPr wrap="square" lIns="36576" tIns="18288" rIns="36576" bIns="18288" anchor="ctr">
+            <a:spAutoFit/>
+          </a:bodyPr>
+          <a:lstStyle/>
+          <a:p>
+            <a:pPr algn="ctr">
+              <a:spcBef>
+                <a:spcPts val="0"/>
+              </a:spcBef>
+              <a:spcAft>
+                <a:spcPts val="200"/>
+              </a:spcAft>
+            </a:pPr>
+            <a:r>
+              <a:rPr sz="1400" b="1" dirty="0">
+                <a:solidFill>
+                  <a:srgbClr val="004B9E"/>
+                </a:solidFill>
+                <a:latin typeface="Times New Roman" panose="02020603050405020304" pitchFamily="18" charset="0"/>
+                <a:cs typeface="Times New Roman" panose="02020603050405020304" pitchFamily="18" charset="0"/>
+              </a:rPr>
+              <a:t>Accessibility &amp; Assistive Tech Literature</a:t>
+            </a:r>
+          </a:p>
+        </p:txBody>
+      </p:sp>
+      <p:pic>
+        <p:nvPicPr>
+          <p:cNvPr id="63" name="Picture 62" descr="kb_shield.png"/>
+          <p:cNvPicPr>
+            <a:picLocks noChangeAspect="1"/>
+          </p:cNvPicPr>
+          <p:nvPr/>
+        </p:nvPicPr>
+        <p:blipFill>
+          <a:blip r:embed="rId5"/>
+          <a:stretch>
+            <a:fillRect/>
+          </a:stretch>
+        </p:blipFill>
+        <p:spPr>
+          <a:xfrm>
+            <a:off x="7798863" y="6634316"/>
+            <a:ext cx="320031" cy="320031"/>
+          </a:xfrm>
+          <a:prstGeom prst="rect">
+            <a:avLst/>
+          </a:prstGeom>
+        </p:spPr>
+      </p:pic>
+      <p:sp>
+        <p:nvSpPr>
+          <p:cNvPr id="64" name="TextBox 63"/>
+          <p:cNvSpPr txBox="1"/>
+          <p:nvPr/>
+        </p:nvSpPr>
+        <p:spPr>
+          <a:xfrm>
+            <a:off x="6916236" y="6833463"/>
+            <a:ext cx="2186885" cy="467820"/>
+          </a:xfrm>
+          <a:prstGeom prst="rect">
+            <a:avLst/>
+          </a:prstGeom>
+          <a:noFill/>
+        </p:spPr>
+        <p:txBody>
+          <a:bodyPr wrap="square" lIns="36576" tIns="18288" rIns="36576" bIns="18288" anchor="ctr">
+            <a:spAutoFit/>
+          </a:bodyPr>
+          <a:lstStyle/>
+          <a:p>
+            <a:pPr algn="ctr">
+              <a:spcBef>
+                <a:spcPts val="0"/>
+              </a:spcBef>
+              <a:spcAft>
+                <a:spcPts val="200"/>
+              </a:spcAft>
+            </a:pPr>
+            <a:r>
+              <a:rPr sz="1400" b="1" dirty="0">
+                <a:solidFill>
+                  <a:srgbClr val="004B9E"/>
+                </a:solidFill>
+                <a:latin typeface="Times New Roman" panose="02020603050405020304" pitchFamily="18" charset="0"/>
+                <a:cs typeface="Times New Roman" panose="02020603050405020304" pitchFamily="18" charset="0"/>
+              </a:rPr>
+              <a:t>Standards and Guidelines (WCAG, GDPR, EN 301)</a:t>
+            </a:r>
+          </a:p>
+        </p:txBody>
+      </p:sp>
+      <p:pic>
+        <p:nvPicPr>
+          <p:cNvPr id="65" name="Picture 64" descr="kb_gear.png"/>
+          <p:cNvPicPr>
+            <a:picLocks noChangeAspect="1"/>
+          </p:cNvPicPr>
+          <p:nvPr/>
+        </p:nvPicPr>
+        <p:blipFill>
+          <a:blip r:embed="rId6"/>
+          <a:stretch>
+            <a:fillRect/>
+          </a:stretch>
+        </p:blipFill>
+        <p:spPr>
+          <a:xfrm>
+            <a:off x="10188945" y="6621616"/>
+            <a:ext cx="320031" cy="320031"/>
+          </a:xfrm>
+          <a:prstGeom prst="rect">
+            <a:avLst/>
+          </a:prstGeom>
+        </p:spPr>
+      </p:pic>
+      <p:sp>
+        <p:nvSpPr>
+          <p:cNvPr id="66" name="TextBox 65"/>
+          <p:cNvSpPr txBox="1"/>
+          <p:nvPr/>
+        </p:nvSpPr>
+        <p:spPr>
+          <a:xfrm>
+            <a:off x="9189490" y="6833464"/>
+            <a:ext cx="2659313" cy="467820"/>
+          </a:xfrm>
+          <a:prstGeom prst="rect">
+            <a:avLst/>
+          </a:prstGeom>
+          <a:noFill/>
+        </p:spPr>
+        <p:txBody>
+          <a:bodyPr wrap="square" lIns="36576" tIns="18288" rIns="36576" bIns="18288" anchor="ctr">
+            <a:spAutoFit/>
+          </a:bodyPr>
+          <a:lstStyle/>
+          <a:p>
+            <a:pPr algn="ctr">
+              <a:spcBef>
+                <a:spcPts val="0"/>
+              </a:spcBef>
+              <a:spcAft>
+                <a:spcPts val="200"/>
+              </a:spcAft>
+            </a:pPr>
+            <a:r>
+              <a:rPr sz="1400" b="1" dirty="0">
+                <a:solidFill>
+                  <a:srgbClr val="004B9E"/>
+                </a:solidFill>
+                <a:latin typeface="Times New Roman" panose="02020603050405020304" pitchFamily="18" charset="0"/>
+                <a:cs typeface="Times New Roman" panose="02020603050405020304" pitchFamily="18" charset="0"/>
+              </a:rPr>
+              <a:t>Tools and Platforms (Lighthouse, WAVE, </a:t>
+            </a:r>
+            <a:r>
+              <a:rPr lang="en-US" sz="1400" b="1" dirty="0">
+                <a:solidFill>
+                  <a:srgbClr val="004B9E"/>
+                </a:solidFill>
+                <a:latin typeface="Times New Roman" panose="02020603050405020304" pitchFamily="18" charset="0"/>
+                <a:cs typeface="Times New Roman" panose="02020603050405020304" pitchFamily="18" charset="0"/>
+              </a:rPr>
+              <a:t>Axe </a:t>
+            </a:r>
+            <a:r>
+              <a:rPr lang="en-US" sz="1400" b="1" dirty="0" err="1">
+                <a:solidFill>
+                  <a:srgbClr val="004B9E"/>
+                </a:solidFill>
+                <a:latin typeface="Times New Roman" panose="02020603050405020304" pitchFamily="18" charset="0"/>
+                <a:cs typeface="Times New Roman" panose="02020603050405020304" pitchFamily="18" charset="0"/>
+              </a:rPr>
+              <a:t>DevTools</a:t>
+            </a:r>
+            <a:r>
+              <a:rPr sz="1400" b="1" dirty="0">
+                <a:solidFill>
+                  <a:srgbClr val="004B9E"/>
+                </a:solidFill>
+                <a:latin typeface="Times New Roman" panose="02020603050405020304" pitchFamily="18" charset="0"/>
+                <a:cs typeface="Times New Roman" panose="02020603050405020304" pitchFamily="18" charset="0"/>
+              </a:rPr>
+              <a:t>)</a:t>
+            </a:r>
+          </a:p>
+        </p:txBody>
+      </p:sp>
+      <p:cxnSp>
+        <p:nvCxnSpPr>
+          <p:cNvPr id="67" name="Connector 66"/>
+          <p:cNvCxnSpPr/>
+          <p:nvPr/>
+        </p:nvCxnSpPr>
+        <p:spPr>
+          <a:xfrm>
+            <a:off x="10934426" y="4533786"/>
+            <a:ext cx="0" cy="166214"/>
+          </a:xfrm>
+          <a:prstGeom prst="line">
+            <a:avLst/>
+          </a:prstGeom>
+          <a:ln w="19050">
+            <a:solidFill>
+              <a:srgbClr val="B5651D"/>
+            </a:solidFill>
+            <a:prstDash val="dash"/>
+            <a:tailEnd type="triangle" w="med" len="med"/>
+          </a:ln>
+        </p:spPr>
+        <p:style>
+          <a:lnRef idx="2">
+            <a:schemeClr val="accent1"/>
+          </a:lnRef>
+          <a:fillRef idx="0">
+            <a:schemeClr val="accent1"/>
+          </a:fillRef>
+          <a:effectRef idx="1">
+            <a:schemeClr val="accent1"/>
+          </a:effectRef>
+          <a:fontRef idx="minor">
+            <a:schemeClr val="tx1"/>
+          </a:fontRef>
+        </p:style>
+      </p:cxnSp>
+      <p:sp>
+        <p:nvSpPr>
+          <p:cNvPr id="68" name="Rounded Rectangle 67"/>
+          <p:cNvSpPr/>
+          <p:nvPr/>
+        </p:nvSpPr>
+        <p:spPr>
+          <a:xfrm>
+            <a:off x="9943851" y="4700000"/>
+            <a:ext cx="1981150" cy="1400000"/>
+          </a:xfrm>
+          <a:prstGeom prst="roundRect">
+            <a:avLst>
+              <a:gd name="adj" fmla="val 3000"/>
+            </a:avLst>
+          </a:prstGeom>
+          <a:solidFill>
+            <a:srgbClr val="F4F6F8"/>
+          </a:solidFill>
+          <a:ln w="20320">
+            <a:solidFill>
+              <a:srgbClr val="B5651D"/>
+            </a:solidFill>
+            <a:prstDash val="dash"/>
+          </a:ln>
+          <a:effectLst/>
+        </p:spPr>
+        <p:style>
+          <a:lnRef idx="1">
+            <a:schemeClr val="accent1"/>
+          </a:lnRef>
+          <a:fillRef idx="3">
+            <a:schemeClr val="accent1"/>
+          </a:fillRef>
+          <a:effectRef idx="2">
+            <a:schemeClr val="accent1"/>
+          </a:effectRef>
+          <a:fontRef idx="minor">
+            <a:schemeClr val="lt1"/>
+          </a:fontRef>
+        </p:style>
+        <p:txBody>
+          <a:bodyPr rtlCol="0" anchor="ctr"/>
+          <a:lstStyle/>
+          <a:p>
+            <a:pPr algn="ctr"/>
+            <a:endParaRPr>
+              <a:latin typeface="Times New Roman" panose="02020603050405020304" pitchFamily="18" charset="0"/>
+              <a:cs typeface="Times New Roman" panose="02020603050405020304" pitchFamily="18" charset="0"/>
+            </a:endParaRPr>
+          </a:p>
+        </p:txBody>
+      </p:sp>
+      <p:sp>
+        <p:nvSpPr>
+          <p:cNvPr id="69" name="Oval 68"/>
+          <p:cNvSpPr/>
+          <p:nvPr/>
+        </p:nvSpPr>
+        <p:spPr>
+          <a:xfrm>
+            <a:off x="10003851" y="4770000"/>
+            <a:ext cx="260000" cy="260000"/>
+          </a:xfrm>
+          <a:prstGeom prst="ellipse">
+            <a:avLst/>
+          </a:prstGeom>
+          <a:solidFill>
+            <a:srgbClr val="FFFFFF"/>
+          </a:solidFill>
+          <a:ln w="20320">
+            <a:solidFill>
+              <a:srgbClr val="B5651D"/>
+            </a:solidFill>
+            <a:prstDash val="dash"/>
+          </a:ln>
+          <a:effectLst/>
+        </p:spPr>
+        <p:style>
+          <a:lnRef idx="1">
+            <a:schemeClr val="accent1"/>
+          </a:lnRef>
+          <a:fillRef idx="3">
+            <a:schemeClr val="accent1"/>
+          </a:fillRef>
+          <a:effectRef idx="2">
+            <a:schemeClr val="accent1"/>
+          </a:effectRef>
+          <a:fontRef idx="minor">
+            <a:schemeClr val="lt1"/>
+          </a:fontRef>
+        </p:style>
+        <p:txBody>
+          <a:bodyPr wrap="square" lIns="0" tIns="0" rIns="0" bIns="0" rtlCol="0" anchor="ctr"/>
+          <a:lstStyle/>
+          <a:p>
+            <a:pPr algn="ctr">
+              <a:spcBef>
+                <a:spcPts val="0"/>
+              </a:spcBef>
+              <a:spcAft>
+                <a:spcPts val="0"/>
+              </a:spcAft>
+            </a:pPr>
+            <a:r>
+              <a:rPr sz="1100" b="1" i="0">
+                <a:solidFill>
+                  <a:srgbClr val="B5651D"/>
+                </a:solidFill>
+                <a:latin typeface="Times New Roman" panose="02020603050405020304" pitchFamily="18" charset="0"/>
+                <a:cs typeface="Times New Roman" panose="02020603050405020304" pitchFamily="18" charset="0"/>
+              </a:rPr>
+              <a:t>6</a:t>
+            </a:r>
+          </a:p>
+        </p:txBody>
+      </p:sp>
+      <p:sp>
+        <p:nvSpPr>
+          <p:cNvPr id="70" name="TextBox 69"/>
+          <p:cNvSpPr txBox="1"/>
+          <p:nvPr/>
+        </p:nvSpPr>
+        <p:spPr>
+          <a:xfrm>
+            <a:off x="10310000" y="4735000"/>
+            <a:ext cx="1560000" cy="530000"/>
+          </a:xfrm>
+          <a:prstGeom prst="rect">
+            <a:avLst/>
+          </a:prstGeom>
+          <a:noFill/>
+        </p:spPr>
+        <p:txBody>
+          <a:bodyPr wrap="square" lIns="18288" tIns="9144" rIns="18288" bIns="9144" anchor="ctr">
+            <a:normAutofit fontScale="97500"/>
+          </a:bodyPr>
+          <a:lstStyle/>
+          <a:p>
+            <a:pPr algn="l">
+              <a:spcBef>
+                <a:spcPts val="0"/>
+              </a:spcBef>
+              <a:spcAft>
+                <a:spcPts val="0"/>
+              </a:spcAft>
+            </a:pPr>
+            <a:r>
+              <a:rPr sz="1200" b="1" i="0" dirty="0">
+                <a:solidFill>
+                  <a:srgbClr val="B5651D"/>
+                </a:solidFill>
+                <a:latin typeface="Times New Roman" panose="02020603050405020304" pitchFamily="18" charset="0"/>
+                <a:cs typeface="Times New Roman" panose="02020603050405020304" pitchFamily="18" charset="0"/>
+              </a:rPr>
+              <a:t>PwD VALIDATION</a:t>
+            </a:r>
+          </a:p>
+          <a:p>
+            <a:pPr algn="l">
+              <a:spcBef>
+                <a:spcPts val="0"/>
+              </a:spcBef>
+              <a:spcAft>
+                <a:spcPts val="0"/>
+              </a:spcAft>
+            </a:pPr>
+            <a:r>
+              <a:rPr sz="1200" b="0" dirty="0">
+                <a:latin typeface="Times New Roman" panose="02020603050405020304" pitchFamily="18" charset="0"/>
+                <a:cs typeface="Times New Roman" panose="02020603050405020304" pitchFamily="18" charset="0"/>
+              </a:rPr>
+              <a:t>(Planned</a:t>
+            </a:r>
+            <a:r>
+              <a:rPr lang="en-US" sz="1200" b="0" dirty="0">
+                <a:latin typeface="Times New Roman" panose="02020603050405020304" pitchFamily="18" charset="0"/>
+                <a:cs typeface="Times New Roman" panose="02020603050405020304" pitchFamily="18" charset="0"/>
+              </a:rPr>
+              <a:t>)</a:t>
+            </a:r>
+            <a:endParaRPr sz="1200" b="0" dirty="0">
+              <a:latin typeface="Times New Roman" panose="02020603050405020304" pitchFamily="18" charset="0"/>
+              <a:cs typeface="Times New Roman" panose="02020603050405020304" pitchFamily="18" charset="0"/>
+            </a:endParaRPr>
+          </a:p>
+        </p:txBody>
+      </p:sp>
+      <p:sp>
+        <p:nvSpPr>
+          <p:cNvPr id="71" name="TextBox 70"/>
+          <p:cNvSpPr txBox="1"/>
+          <p:nvPr/>
+        </p:nvSpPr>
+        <p:spPr>
+          <a:xfrm>
+            <a:off x="10030000" y="5211100"/>
+            <a:ext cx="1830000" cy="760000"/>
+          </a:xfrm>
+          <a:prstGeom prst="rect">
+            <a:avLst/>
+          </a:prstGeom>
+          <a:noFill/>
+        </p:spPr>
+        <p:txBody>
+          <a:bodyPr wrap="square" lIns="18288" tIns="9144" rIns="18288" bIns="9144" anchor="t">
+            <a:noAutofit/>
+          </a:bodyPr>
+          <a:lstStyle/>
+          <a:p>
+            <a:pPr algn="l">
+              <a:lnSpc>
+                <a:spcPct val="130000"/>
+              </a:lnSpc>
+              <a:spcBef>
+                <a:spcPts val="0"/>
+              </a:spcBef>
+              <a:spcAft>
+                <a:spcPts val="0"/>
+              </a:spcAft>
+            </a:pPr>
+            <a:r>
+              <a:rPr sz="1100" b="1" i="0" dirty="0">
+                <a:latin typeface="Times New Roman" panose="02020603050405020304" pitchFamily="18" charset="0"/>
+                <a:cs typeface="Times New Roman" panose="02020603050405020304" pitchFamily="18" charset="0"/>
+              </a:rPr>
+              <a:t>•  </a:t>
+            </a:r>
+            <a:r>
+              <a:rPr sz="1100" b="0" i="0" dirty="0">
+                <a:latin typeface="Times New Roman" panose="02020603050405020304" pitchFamily="18" charset="0"/>
+                <a:cs typeface="Times New Roman" panose="02020603050405020304" pitchFamily="18" charset="0"/>
+              </a:rPr>
+              <a:t>Empirical validation with PwD participants; pre-specified protocol , execution pending.</a:t>
+            </a:r>
+          </a:p>
+        </p:txBody>
+      </p:sp>
     </p:spTree>
   </p:cSld>
   <p:clrMapOvr>

</xml_diff>